<commit_message>
docs: fix orphan report page; feature login/register screenshots
Keep Assignment 4 on one page with folder structure figure.
Make Sign in / Create account the primary Assignment 6 figures
and enlarge them on the PPT auth + gallery slides.

Co-authored-by: Cursor <cursoragent@cursor.com>
</commit_message>
<xml_diff>
--- a/docs/submission/Tanmay_Shinde_CPAD_Assignments_1-10_ARCHIVE_Presentation.pptx
+++ b/docs/submission/Tanmay_Shinde_CPAD_Assignments_1-10_ARCHIVE_Presentation.pptx
@@ -29,6 +29,7 @@
     <p:sldId id="277" r:id="rId28"/>
     <p:sldId id="278" r:id="rId29"/>
     <p:sldId id="279" r:id="rId30"/>
+    <p:sldId id="280" r:id="rId31"/>
   </p:sldIdLst>
   <p:sldSz cx="12191695" cy="6858000" type="screen4x3"/>
   <p:notesSz cx="6858000" cy="9144000"/>
@@ -3777,124 +3778,9 @@
           </a:p>
         </p:txBody>
       </p:sp>
-      <p:sp>
-        <p:nvSpPr>
-          <p:cNvPr id="5" name="TextBox 4"/>
-          <p:cNvSpPr txBox="1"/>
-          <p:nvPr/>
-        </p:nvSpPr>
-        <p:spPr>
-          <a:xfrm>
-            <a:off x="502920" y="1417320"/>
-            <a:ext cx="5303520" cy="4754880"/>
-          </a:xfrm>
-          <a:prstGeom prst="rect">
-            <a:avLst/>
-          </a:prstGeom>
-          <a:noFill/>
-        </p:spPr>
-        <p:txBody>
-          <a:bodyPr wrap="none">
-            <a:spAutoFit/>
-          </a:bodyPr>
-          <a:lstStyle/>
-          <a:p>
-            <a:pPr algn="l"/>
-            <a:r>
-              <a:rPr sz="1500" b="0">
-                <a:solidFill>
-                  <a:srgbClr val="181510"/>
-                </a:solidFill>
-                <a:latin typeface="Calibri"/>
-              </a:rPr>
-              <a:t>•  AuthContext stores accounts + session in AsyncStorage</a:t>
-            </a:r>
-          </a:p>
-          <a:p>
-            <a:pPr>
-              <a:spcBef>
-                <a:spcPts val="1200"/>
-              </a:spcBef>
-            </a:pPr>
-            <a:r>
-              <a:rPr sz="1500" b="0">
-                <a:solidFill>
-                  <a:srgbClr val="181510"/>
-                </a:solidFill>
-                <a:latin typeface="Calibri"/>
-              </a:rPr>
-              <a:t>•  Create account: name, email, phone, password (min 6)</a:t>
-            </a:r>
-          </a:p>
-          <a:p>
-            <a:pPr>
-              <a:spcBef>
-                <a:spcPts val="1200"/>
-              </a:spcBef>
-            </a:pPr>
-            <a:r>
-              <a:rPr sz="1500" b="0">
-                <a:solidFill>
-                  <a:srgbClr val="181510"/>
-                </a:solidFill>
-                <a:latin typeface="Calibri"/>
-              </a:rPr>
-              <a:t>•  Sign in unlocks Checkout and a real Profile</a:t>
-            </a:r>
-          </a:p>
-          <a:p>
-            <a:pPr>
-              <a:spcBef>
-                <a:spcPts val="1200"/>
-              </a:spcBef>
-            </a:pPr>
-            <a:r>
-              <a:rPr sz="1500" b="0">
-                <a:solidFill>
-                  <a:srgbClr val="181510"/>
-                </a:solidFill>
-                <a:latin typeface="Calibri"/>
-              </a:rPr>
-              <a:t>•  Guest Profile shows Sign in / Create account CTAs</a:t>
-            </a:r>
-          </a:p>
-          <a:p>
-            <a:pPr>
-              <a:spcBef>
-                <a:spcPts val="1200"/>
-              </a:spcBef>
-            </a:pPr>
-            <a:r>
-              <a:rPr sz="1500" b="0">
-                <a:solidFill>
-                  <a:srgbClr val="181510"/>
-                </a:solidFill>
-                <a:latin typeface="Calibri"/>
-              </a:rPr>
-              <a:t>•  In-app popups for welcome, errors, and order placed</a:t>
-            </a:r>
-          </a:p>
-          <a:p>
-            <a:pPr>
-              <a:spcBef>
-                <a:spcPts val="1200"/>
-              </a:spcBef>
-            </a:pPr>
-            <a:r>
-              <a:rPr sz="1500" b="0">
-                <a:solidFill>
-                  <a:srgbClr val="181510"/>
-                </a:solidFill>
-                <a:latin typeface="Calibri"/>
-              </a:rPr>
-              <a:t>•  Cart remains saved across the auth redirect</a:t>
-            </a:r>
-          </a:p>
-        </p:txBody>
-      </p:sp>
       <p:pic>
         <p:nvPicPr>
-          <p:cNvPr id="6" name="Picture 5" descr="12_login.png"/>
+          <p:cNvPr id="5" name="Picture 4" descr="12_login.png"/>
           <p:cNvPicPr>
             <a:picLocks noChangeAspect="1"/>
           </p:cNvPicPr>
@@ -3908,8 +3794,8 @@
         </p:blipFill>
         <p:spPr>
           <a:xfrm>
-            <a:off x="5943600" y="1234440"/>
-            <a:ext cx="2408426" cy="5212080"/>
+            <a:off x="411480" y="1234440"/>
+            <a:ext cx="2471805" cy="5349240"/>
           </a:xfrm>
           <a:prstGeom prst="rect">
             <a:avLst/>
@@ -3918,7 +3804,7 @@
       </p:pic>
       <p:pic>
         <p:nvPicPr>
-          <p:cNvPr id="7" name="Picture 6" descr="13_register.png"/>
+          <p:cNvPr id="6" name="Picture 5" descr="13_register.png"/>
           <p:cNvPicPr>
             <a:picLocks noChangeAspect="1"/>
           </p:cNvPicPr>
@@ -3932,14 +3818,129 @@
         </p:blipFill>
         <p:spPr>
           <a:xfrm>
-            <a:off x="9006840" y="1234440"/>
-            <a:ext cx="2408426" cy="5212080"/>
+            <a:off x="3246120" y="1234440"/>
+            <a:ext cx="2471805" cy="5349240"/>
           </a:xfrm>
           <a:prstGeom prst="rect">
             <a:avLst/>
           </a:prstGeom>
         </p:spPr>
       </p:pic>
+      <p:sp>
+        <p:nvSpPr>
+          <p:cNvPr id="7" name="TextBox 6"/>
+          <p:cNvSpPr txBox="1"/>
+          <p:nvPr/>
+        </p:nvSpPr>
+        <p:spPr>
+          <a:xfrm>
+            <a:off x="6263640" y="1417320"/>
+            <a:ext cx="5394960" cy="4754880"/>
+          </a:xfrm>
+          <a:prstGeom prst="rect">
+            <a:avLst/>
+          </a:prstGeom>
+          <a:noFill/>
+        </p:spPr>
+        <p:txBody>
+          <a:bodyPr wrap="none">
+            <a:spAutoFit/>
+          </a:bodyPr>
+          <a:lstStyle/>
+          <a:p>
+            <a:pPr algn="l"/>
+            <a:r>
+              <a:rPr sz="1600" b="0">
+                <a:solidFill>
+                  <a:srgbClr val="181510"/>
+                </a:solidFill>
+                <a:latin typeface="Calibri"/>
+              </a:rPr>
+              <a:t>•  AuthContext + AsyncStorage session</a:t>
+            </a:r>
+          </a:p>
+          <a:p>
+            <a:pPr>
+              <a:spcBef>
+                <a:spcPts val="1200"/>
+              </a:spcBef>
+            </a:pPr>
+            <a:r>
+              <a:rPr sz="1600" b="0">
+                <a:solidFill>
+                  <a:srgbClr val="181510"/>
+                </a:solidFill>
+                <a:latin typeface="Calibri"/>
+              </a:rPr>
+              <a:t>•  Create account: name, email, phone, password</a:t>
+            </a:r>
+          </a:p>
+          <a:p>
+            <a:pPr>
+              <a:spcBef>
+                <a:spcPts val="1200"/>
+              </a:spcBef>
+            </a:pPr>
+            <a:r>
+              <a:rPr sz="1600" b="0">
+                <a:solidFill>
+                  <a:srgbClr val="181510"/>
+                </a:solidFill>
+                <a:latin typeface="Calibri"/>
+              </a:rPr>
+              <a:t>•  Sign in unlocks Checkout + Profile</a:t>
+            </a:r>
+          </a:p>
+          <a:p>
+            <a:pPr>
+              <a:spcBef>
+                <a:spcPts val="1200"/>
+              </a:spcBef>
+            </a:pPr>
+            <a:r>
+              <a:rPr sz="1600" b="0">
+                <a:solidFill>
+                  <a:srgbClr val="181510"/>
+                </a:solidFill>
+                <a:latin typeface="Calibri"/>
+              </a:rPr>
+              <a:t>•  Guest can still add to cart</a:t>
+            </a:r>
+          </a:p>
+          <a:p>
+            <a:pPr>
+              <a:spcBef>
+                <a:spcPts val="1200"/>
+              </a:spcBef>
+            </a:pPr>
+            <a:r>
+              <a:rPr sz="1600" b="0">
+                <a:solidFill>
+                  <a:srgbClr val="181510"/>
+                </a:solidFill>
+                <a:latin typeface="Calibri"/>
+              </a:rPr>
+              <a:t>•  Popups: welcome, errors, order placed</a:t>
+            </a:r>
+          </a:p>
+          <a:p>
+            <a:pPr>
+              <a:spcBef>
+                <a:spcPts val="1200"/>
+              </a:spcBef>
+            </a:pPr>
+            <a:r>
+              <a:rPr sz="1600" b="0">
+                <a:solidFill>
+                  <a:srgbClr val="181510"/>
+                </a:solidFill>
+                <a:latin typeface="Calibri"/>
+              </a:rPr>
+              <a:t>•  Cart saved across auth redirect</a:t>
+            </a:r>
+          </a:p>
+        </p:txBody>
+      </p:sp>
     </p:spTree>
   </p:cSld>
   <p:clrMapOvr>
@@ -5284,7 +5285,7 @@
                 </a:solidFill>
                 <a:latin typeface="Calibri"/>
               </a:rPr>
-              <a:t>UI gallery — brand &amp; platform</a:t>
+              <a:t>UI gallery — authentication</a:t>
             </a:r>
           </a:p>
         </p:txBody>
@@ -5362,14 +5363,14 @@
                 </a:solidFill>
                 <a:latin typeface="Calibri"/>
               </a:rPr>
-              <a:t>About · How we build · Tabs</a:t>
+              <a:t>Sign in · Create account</a:t>
             </a:r>
           </a:p>
         </p:txBody>
       </p:sp>
       <p:pic>
         <p:nvPicPr>
-          <p:cNvPr id="5" name="Picture 4" descr="09_about.png"/>
+          <p:cNvPr id="5" name="Picture 4" descr="12_login.png"/>
           <p:cNvPicPr>
             <a:picLocks noChangeAspect="1"/>
           </p:cNvPicPr>
@@ -5383,8 +5384,8 @@
         </p:blipFill>
         <p:spPr>
           <a:xfrm>
-            <a:off x="1005840" y="1325880"/>
-            <a:ext cx="2366173" cy="5120640"/>
+            <a:off x="2011680" y="1143000"/>
+            <a:ext cx="2492932" cy="5394960"/>
           </a:xfrm>
           <a:prstGeom prst="rect">
             <a:avLst/>
@@ -5393,7 +5394,7 @@
       </p:pic>
       <p:pic>
         <p:nvPicPr>
-          <p:cNvPr id="6" name="Picture 5" descr="10_tech.png"/>
+          <p:cNvPr id="6" name="Picture 5" descr="13_register.png"/>
           <p:cNvPicPr>
             <a:picLocks noChangeAspect="1"/>
           </p:cNvPicPr>
@@ -5407,32 +5408,8 @@
         </p:blipFill>
         <p:spPr>
           <a:xfrm>
-            <a:off x="4480560" y="1325880"/>
-            <a:ext cx="2366173" cy="5120640"/>
-          </a:xfrm>
-          <a:prstGeom prst="rect">
-            <a:avLst/>
-          </a:prstGeom>
-        </p:spPr>
-      </p:pic>
-      <p:pic>
-        <p:nvPicPr>
-          <p:cNvPr id="7" name="Picture 6" descr="11_tabs.png"/>
-          <p:cNvPicPr>
-            <a:picLocks noChangeAspect="1"/>
-          </p:cNvPicPr>
-          <p:nvPr/>
-        </p:nvPicPr>
-        <p:blipFill>
-          <a:blip r:embed="rId4"/>
-          <a:stretch>
-            <a:fillRect/>
-          </a:stretch>
-        </p:blipFill>
-        <p:spPr>
-          <a:xfrm>
-            <a:off x="7955279" y="1325880"/>
-            <a:ext cx="2366173" cy="5120640"/>
+            <a:off x="6309360" y="1143000"/>
+            <a:ext cx="2492932" cy="5394960"/>
           </a:xfrm>
           <a:prstGeom prst="rect">
             <a:avLst/>
@@ -5448,6 +5425,217 @@
 </file>
 
 <file path=ppt/slides/slide18.xml><?xml version="1.0" encoding="utf-8"?>
+<p:sld xmlns:a="http://schemas.openxmlformats.org/drawingml/2006/main" xmlns:p="http://schemas.openxmlformats.org/presentationml/2006/main" xmlns:r="http://schemas.openxmlformats.org/officeDocument/2006/relationships">
+  <p:cSld>
+    <p:bg>
+      <p:bgPr>
+        <a:solidFill>
+          <a:srgbClr val="F2EEE6"/>
+        </a:solidFill>
+        <a:effectLst/>
+      </p:bgPr>
+    </p:bg>
+    <p:spTree>
+      <p:nvGrpSpPr>
+        <p:cNvPr id="1" name=""/>
+        <p:cNvGrpSpPr/>
+        <p:nvPr/>
+      </p:nvGrpSpPr>
+      <p:grpSpPr/>
+      <p:sp>
+        <p:nvSpPr>
+          <p:cNvPr id="2" name="TextBox 1"/>
+          <p:cNvSpPr txBox="1"/>
+          <p:nvPr/>
+        </p:nvSpPr>
+        <p:spPr>
+          <a:xfrm>
+            <a:off x="548640" y="292608"/>
+            <a:ext cx="10972800" cy="502920"/>
+          </a:xfrm>
+          <a:prstGeom prst="rect">
+            <a:avLst/>
+          </a:prstGeom>
+          <a:noFill/>
+        </p:spPr>
+        <p:txBody>
+          <a:bodyPr wrap="none">
+            <a:spAutoFit/>
+          </a:bodyPr>
+          <a:lstStyle/>
+          <a:p>
+            <a:pPr algn="l"/>
+            <a:r>
+              <a:rPr sz="2600" b="1">
+                <a:solidFill>
+                  <a:srgbClr val="181510"/>
+                </a:solidFill>
+                <a:latin typeface="Calibri"/>
+              </a:rPr>
+              <a:t>UI gallery — brand &amp; platform</a:t>
+            </a:r>
+          </a:p>
+        </p:txBody>
+      </p:sp>
+      <p:sp>
+        <p:nvSpPr>
+          <p:cNvPr id="3" name="Rectangle 2"/>
+          <p:cNvSpPr/>
+          <p:nvPr/>
+        </p:nvSpPr>
+        <p:spPr>
+          <a:xfrm>
+            <a:off x="548640" y="914400"/>
+            <a:ext cx="1097280" cy="54864"/>
+          </a:xfrm>
+          <a:prstGeom prst="rect">
+            <a:avLst/>
+          </a:prstGeom>
+          <a:solidFill>
+            <a:srgbClr val="A9522F"/>
+          </a:solidFill>
+          <a:ln>
+            <a:noFill/>
+          </a:ln>
+        </p:spPr>
+        <p:style>
+          <a:lnRef idx="1">
+            <a:schemeClr val="accent1"/>
+          </a:lnRef>
+          <a:fillRef idx="3">
+            <a:schemeClr val="accent1"/>
+          </a:fillRef>
+          <a:effectRef idx="2">
+            <a:schemeClr val="accent1"/>
+          </a:effectRef>
+          <a:fontRef idx="minor">
+            <a:schemeClr val="lt1"/>
+          </a:fontRef>
+        </p:style>
+        <p:txBody>
+          <a:bodyPr rtlCol="0" anchor="ctr"/>
+          <a:lstStyle/>
+          <a:p>
+            <a:pPr algn="ctr"/>
+          </a:p>
+        </p:txBody>
+      </p:sp>
+      <p:sp>
+        <p:nvSpPr>
+          <p:cNvPr id="4" name="TextBox 3"/>
+          <p:cNvSpPr txBox="1"/>
+          <p:nvPr/>
+        </p:nvSpPr>
+        <p:spPr>
+          <a:xfrm>
+            <a:off x="548640" y="1051560"/>
+            <a:ext cx="10972800" cy="365760"/>
+          </a:xfrm>
+          <a:prstGeom prst="rect">
+            <a:avLst/>
+          </a:prstGeom>
+          <a:noFill/>
+        </p:spPr>
+        <p:txBody>
+          <a:bodyPr wrap="none">
+            <a:spAutoFit/>
+          </a:bodyPr>
+          <a:lstStyle/>
+          <a:p>
+            <a:pPr algn="l"/>
+            <a:r>
+              <a:rPr sz="1400" b="0">
+                <a:solidFill>
+                  <a:srgbClr val="5C5648"/>
+                </a:solidFill>
+                <a:latin typeface="Calibri"/>
+              </a:rPr>
+              <a:t>About · How we build · Tabs</a:t>
+            </a:r>
+          </a:p>
+        </p:txBody>
+      </p:sp>
+      <p:pic>
+        <p:nvPicPr>
+          <p:cNvPr id="5" name="Picture 4" descr="09_about.png"/>
+          <p:cNvPicPr>
+            <a:picLocks noChangeAspect="1"/>
+          </p:cNvPicPr>
+          <p:nvPr/>
+        </p:nvPicPr>
+        <p:blipFill>
+          <a:blip r:embed="rId2"/>
+          <a:stretch>
+            <a:fillRect/>
+          </a:stretch>
+        </p:blipFill>
+        <p:spPr>
+          <a:xfrm>
+            <a:off x="1005840" y="1325880"/>
+            <a:ext cx="2366173" cy="5120640"/>
+          </a:xfrm>
+          <a:prstGeom prst="rect">
+            <a:avLst/>
+          </a:prstGeom>
+        </p:spPr>
+      </p:pic>
+      <p:pic>
+        <p:nvPicPr>
+          <p:cNvPr id="6" name="Picture 5" descr="10_tech.png"/>
+          <p:cNvPicPr>
+            <a:picLocks noChangeAspect="1"/>
+          </p:cNvPicPr>
+          <p:nvPr/>
+        </p:nvPicPr>
+        <p:blipFill>
+          <a:blip r:embed="rId3"/>
+          <a:stretch>
+            <a:fillRect/>
+          </a:stretch>
+        </p:blipFill>
+        <p:spPr>
+          <a:xfrm>
+            <a:off x="4480560" y="1325880"/>
+            <a:ext cx="2366173" cy="5120640"/>
+          </a:xfrm>
+          <a:prstGeom prst="rect">
+            <a:avLst/>
+          </a:prstGeom>
+        </p:spPr>
+      </p:pic>
+      <p:pic>
+        <p:nvPicPr>
+          <p:cNvPr id="7" name="Picture 6" descr="11_tabs.png"/>
+          <p:cNvPicPr>
+            <a:picLocks noChangeAspect="1"/>
+          </p:cNvPicPr>
+          <p:nvPr/>
+        </p:nvPicPr>
+        <p:blipFill>
+          <a:blip r:embed="rId4"/>
+          <a:stretch>
+            <a:fillRect/>
+          </a:stretch>
+        </p:blipFill>
+        <p:spPr>
+          <a:xfrm>
+            <a:off x="7955279" y="1325880"/>
+            <a:ext cx="2366173" cy="5120640"/>
+          </a:xfrm>
+          <a:prstGeom prst="rect">
+            <a:avLst/>
+          </a:prstGeom>
+        </p:spPr>
+      </p:pic>
+    </p:spTree>
+  </p:cSld>
+  <p:clrMapOvr>
+    <a:masterClrMapping/>
+  </p:clrMapOvr>
+</p:sld>
+</file>
+
+<file path=ppt/slides/slide19.xml><?xml version="1.0" encoding="utf-8"?>
 <p:sld xmlns:a="http://schemas.openxmlformats.org/drawingml/2006/main" xmlns:p="http://schemas.openxmlformats.org/presentationml/2006/main" xmlns:r="http://schemas.openxmlformats.org/officeDocument/2006/relationships">
   <p:cSld>
     <p:bg>
@@ -5863,83 +6051,6 @@
 </p:sld>
 </file>
 
-<file path=ppt/slides/slide19.xml><?xml version="1.0" encoding="utf-8"?>
-<p:sld xmlns:a="http://schemas.openxmlformats.org/drawingml/2006/main" xmlns:p="http://schemas.openxmlformats.org/presentationml/2006/main" xmlns:r="http://schemas.openxmlformats.org/officeDocument/2006/relationships">
-  <p:cSld>
-    <p:bg>
-      <p:bgPr>
-        <a:solidFill>
-          <a:srgbClr val="181510"/>
-        </a:solidFill>
-        <a:effectLst/>
-      </p:bgPr>
-    </p:bg>
-    <p:spTree>
-      <p:nvGrpSpPr>
-        <p:cNvPr id="1" name=""/>
-        <p:cNvGrpSpPr/>
-        <p:nvPr/>
-      </p:nvGrpSpPr>
-      <p:grpSpPr/>
-      <p:sp>
-        <p:nvSpPr>
-          <p:cNvPr id="2" name="TextBox 1"/>
-          <p:cNvSpPr txBox="1"/>
-          <p:nvPr/>
-        </p:nvSpPr>
-        <p:spPr>
-          <a:xfrm>
-            <a:off x="731520" y="2377440"/>
-            <a:ext cx="10515600" cy="1828800"/>
-          </a:xfrm>
-          <a:prstGeom prst="rect">
-            <a:avLst/>
-          </a:prstGeom>
-          <a:noFill/>
-        </p:spPr>
-        <p:txBody>
-          <a:bodyPr wrap="none">
-            <a:spAutoFit/>
-          </a:bodyPr>
-          <a:lstStyle/>
-          <a:p>
-            <a:pPr algn="ctr"/>
-            <a:r>
-              <a:rPr sz="4000" b="1">
-                <a:solidFill>
-                  <a:srgbClr val="F2EEE6"/>
-                </a:solidFill>
-                <a:latin typeface="Calibri"/>
-              </a:rPr>
-              <a:t>CPAD coverage</a:t>
-            </a:r>
-          </a:p>
-          <a:p>
-            <a:pPr>
-              <a:spcBef>
-                <a:spcPts val="1400"/>
-              </a:spcBef>
-            </a:pPr>
-            <a:r>
-              <a:rPr sz="1800" b="0">
-                <a:solidFill>
-                  <a:srgbClr val="A9522F"/>
-                </a:solidFill>
-                <a:latin typeface="Calibri"/>
-              </a:rPr>
-              <a:t>How the same ARCHIVE app satisfies Assignments 1–10</a:t>
-            </a:r>
-          </a:p>
-        </p:txBody>
-      </p:sp>
-    </p:spTree>
-  </p:cSld>
-  <p:clrMapOvr>
-    <a:masterClrMapping/>
-  </p:clrMapOvr>
-</p:sld>
-</file>
-
 <file path=ppt/slides/slide2.xml><?xml version="1.0" encoding="utf-8"?>
 <p:sld xmlns:a="http://schemas.openxmlformats.org/drawingml/2006/main" xmlns:p="http://schemas.openxmlformats.org/presentationml/2006/main" xmlns:r="http://schemas.openxmlformats.org/officeDocument/2006/relationships">
   <p:cSld>
@@ -6235,6 +6346,83 @@
 </file>
 
 <file path=ppt/slides/slide20.xml><?xml version="1.0" encoding="utf-8"?>
+<p:sld xmlns:a="http://schemas.openxmlformats.org/drawingml/2006/main" xmlns:p="http://schemas.openxmlformats.org/presentationml/2006/main" xmlns:r="http://schemas.openxmlformats.org/officeDocument/2006/relationships">
+  <p:cSld>
+    <p:bg>
+      <p:bgPr>
+        <a:solidFill>
+          <a:srgbClr val="181510"/>
+        </a:solidFill>
+        <a:effectLst/>
+      </p:bgPr>
+    </p:bg>
+    <p:spTree>
+      <p:nvGrpSpPr>
+        <p:cNvPr id="1" name=""/>
+        <p:cNvGrpSpPr/>
+        <p:nvPr/>
+      </p:nvGrpSpPr>
+      <p:grpSpPr/>
+      <p:sp>
+        <p:nvSpPr>
+          <p:cNvPr id="2" name="TextBox 1"/>
+          <p:cNvSpPr txBox="1"/>
+          <p:nvPr/>
+        </p:nvSpPr>
+        <p:spPr>
+          <a:xfrm>
+            <a:off x="731520" y="2377440"/>
+            <a:ext cx="10515600" cy="1828800"/>
+          </a:xfrm>
+          <a:prstGeom prst="rect">
+            <a:avLst/>
+          </a:prstGeom>
+          <a:noFill/>
+        </p:spPr>
+        <p:txBody>
+          <a:bodyPr wrap="none">
+            <a:spAutoFit/>
+          </a:bodyPr>
+          <a:lstStyle/>
+          <a:p>
+            <a:pPr algn="ctr"/>
+            <a:r>
+              <a:rPr sz="4000" b="1">
+                <a:solidFill>
+                  <a:srgbClr val="F2EEE6"/>
+                </a:solidFill>
+                <a:latin typeface="Calibri"/>
+              </a:rPr>
+              <a:t>CPAD coverage</a:t>
+            </a:r>
+          </a:p>
+          <a:p>
+            <a:pPr>
+              <a:spcBef>
+                <a:spcPts val="1400"/>
+              </a:spcBef>
+            </a:pPr>
+            <a:r>
+              <a:rPr sz="1800" b="0">
+                <a:solidFill>
+                  <a:srgbClr val="A9522F"/>
+                </a:solidFill>
+                <a:latin typeface="Calibri"/>
+              </a:rPr>
+              <a:t>How the same ARCHIVE app satisfies Assignments 1–10</a:t>
+            </a:r>
+          </a:p>
+        </p:txBody>
+      </p:sp>
+    </p:spTree>
+  </p:cSld>
+  <p:clrMapOvr>
+    <a:masterClrMapping/>
+  </p:clrMapOvr>
+</p:sld>
+</file>
+
+<file path=ppt/slides/slide21.xml><?xml version="1.0" encoding="utf-8"?>
 <p:sld xmlns:a="http://schemas.openxmlformats.org/drawingml/2006/main" xmlns:p="http://schemas.openxmlformats.org/presentationml/2006/main" xmlns:r="http://schemas.openxmlformats.org/officeDocument/2006/relationships">
   <p:cSld>
     <p:bg>
@@ -7113,960 +7301,6 @@
 </p:sld>
 </file>
 
-<file path=ppt/slides/slide21.xml><?xml version="1.0" encoding="utf-8"?>
-<p:sld xmlns:a="http://schemas.openxmlformats.org/drawingml/2006/main" xmlns:p="http://schemas.openxmlformats.org/presentationml/2006/main" xmlns:r="http://schemas.openxmlformats.org/officeDocument/2006/relationships">
-  <p:cSld>
-    <p:bg>
-      <p:bgPr>
-        <a:solidFill>
-          <a:srgbClr val="F2EEE6"/>
-        </a:solidFill>
-        <a:effectLst/>
-      </p:bgPr>
-    </p:bg>
-    <p:spTree>
-      <p:nvGrpSpPr>
-        <p:cNvPr id="1" name=""/>
-        <p:cNvGrpSpPr/>
-        <p:nvPr/>
-      </p:nvGrpSpPr>
-      <p:grpSpPr/>
-      <p:sp>
-        <p:nvSpPr>
-          <p:cNvPr id="2" name="TextBox 1"/>
-          <p:cNvSpPr txBox="1"/>
-          <p:nvPr/>
-        </p:nvSpPr>
-        <p:spPr>
-          <a:xfrm>
-            <a:off x="548640" y="292608"/>
-            <a:ext cx="10972800" cy="502920"/>
-          </a:xfrm>
-          <a:prstGeom prst="rect">
-            <a:avLst/>
-          </a:prstGeom>
-          <a:noFill/>
-        </p:spPr>
-        <p:txBody>
-          <a:bodyPr wrap="none">
-            <a:spAutoFit/>
-          </a:bodyPr>
-          <a:lstStyle/>
-          <a:p>
-            <a:pPr algn="l"/>
-            <a:r>
-              <a:rPr sz="2600" b="1">
-                <a:solidFill>
-                  <a:srgbClr val="181510"/>
-                </a:solidFill>
-                <a:latin typeface="Calibri"/>
-              </a:rPr>
-              <a:t>Assignment highlights</a:t>
-            </a:r>
-          </a:p>
-        </p:txBody>
-      </p:sp>
-      <p:sp>
-        <p:nvSpPr>
-          <p:cNvPr id="3" name="Rectangle 2"/>
-          <p:cNvSpPr/>
-          <p:nvPr/>
-        </p:nvSpPr>
-        <p:spPr>
-          <a:xfrm>
-            <a:off x="548640" y="914400"/>
-            <a:ext cx="1097280" cy="54864"/>
-          </a:xfrm>
-          <a:prstGeom prst="rect">
-            <a:avLst/>
-          </a:prstGeom>
-          <a:solidFill>
-            <a:srgbClr val="A9522F"/>
-          </a:solidFill>
-          <a:ln>
-            <a:noFill/>
-          </a:ln>
-        </p:spPr>
-        <p:style>
-          <a:lnRef idx="1">
-            <a:schemeClr val="accent1"/>
-          </a:lnRef>
-          <a:fillRef idx="3">
-            <a:schemeClr val="accent1"/>
-          </a:fillRef>
-          <a:effectRef idx="2">
-            <a:schemeClr val="accent1"/>
-          </a:effectRef>
-          <a:fontRef idx="minor">
-            <a:schemeClr val="lt1"/>
-          </a:fontRef>
-        </p:style>
-        <p:txBody>
-          <a:bodyPr rtlCol="0" anchor="ctr"/>
-          <a:lstStyle/>
-          <a:p>
-            <a:pPr algn="ctr"/>
-          </a:p>
-        </p:txBody>
-      </p:sp>
-      <p:sp>
-        <p:nvSpPr>
-          <p:cNvPr id="4" name="TextBox 3"/>
-          <p:cNvSpPr txBox="1"/>
-          <p:nvPr/>
-        </p:nvSpPr>
-        <p:spPr>
-          <a:xfrm>
-            <a:off x="548640" y="1051560"/>
-            <a:ext cx="10972800" cy="365760"/>
-          </a:xfrm>
-          <a:prstGeom prst="rect">
-            <a:avLst/>
-          </a:prstGeom>
-          <a:noFill/>
-        </p:spPr>
-        <p:txBody>
-          <a:bodyPr wrap="none">
-            <a:spAutoFit/>
-          </a:bodyPr>
-          <a:lstStyle/>
-          <a:p>
-            <a:pPr algn="l"/>
-            <a:r>
-              <a:rPr sz="1400" b="0">
-                <a:solidFill>
-                  <a:srgbClr val="5C5648"/>
-                </a:solidFill>
-                <a:latin typeface="Calibri"/>
-              </a:rPr>
-              <a:t>Concept → product surface</a:t>
-            </a:r>
-          </a:p>
-        </p:txBody>
-      </p:sp>
-      <p:sp>
-        <p:nvSpPr>
-          <p:cNvPr id="5" name="Rounded Rectangle 4"/>
-          <p:cNvSpPr/>
-          <p:nvPr/>
-        </p:nvSpPr>
-        <p:spPr>
-          <a:xfrm>
-            <a:off x="365760" y="1417320"/>
-            <a:ext cx="2194560" cy="4846320"/>
-          </a:xfrm>
-          <a:prstGeom prst="roundRect">
-            <a:avLst/>
-          </a:prstGeom>
-          <a:solidFill>
-            <a:srgbClr val="F6F2EA"/>
-          </a:solidFill>
-          <a:ln>
-            <a:solidFill>
-              <a:srgbClr val="C9C0B4"/>
-            </a:solidFill>
-          </a:ln>
-        </p:spPr>
-        <p:style>
-          <a:lnRef idx="1">
-            <a:schemeClr val="accent1"/>
-          </a:lnRef>
-          <a:fillRef idx="3">
-            <a:schemeClr val="accent1"/>
-          </a:fillRef>
-          <a:effectRef idx="2">
-            <a:schemeClr val="accent1"/>
-          </a:effectRef>
-          <a:fontRef idx="minor">
-            <a:schemeClr val="lt1"/>
-          </a:fontRef>
-        </p:style>
-        <p:txBody>
-          <a:bodyPr rtlCol="0" anchor="ctr"/>
-          <a:lstStyle/>
-          <a:p>
-            <a:pPr algn="ctr"/>
-          </a:p>
-        </p:txBody>
-      </p:sp>
-      <p:sp>
-        <p:nvSpPr>
-          <p:cNvPr id="6" name="TextBox 5"/>
-          <p:cNvSpPr txBox="1"/>
-          <p:nvPr/>
-        </p:nvSpPr>
-        <p:spPr>
-          <a:xfrm>
-            <a:off x="475488" y="1554480"/>
-            <a:ext cx="1965960" cy="365760"/>
-          </a:xfrm>
-          <a:prstGeom prst="rect">
-            <a:avLst/>
-          </a:prstGeom>
-          <a:noFill/>
-        </p:spPr>
-        <p:txBody>
-          <a:bodyPr wrap="none">
-            <a:spAutoFit/>
-          </a:bodyPr>
-          <a:lstStyle/>
-          <a:p>
-            <a:pPr algn="l"/>
-            <a:r>
-              <a:rPr sz="1400" b="1">
-                <a:solidFill>
-                  <a:srgbClr val="A9522F"/>
-                </a:solidFill>
-                <a:latin typeface="Calibri"/>
-              </a:rPr>
-              <a:t>A1–A2</a:t>
-            </a:r>
-          </a:p>
-        </p:txBody>
-      </p:sp>
-      <p:sp>
-        <p:nvSpPr>
-          <p:cNvPr id="7" name="TextBox 6"/>
-          <p:cNvSpPr txBox="1"/>
-          <p:nvPr/>
-        </p:nvSpPr>
-        <p:spPr>
-          <a:xfrm>
-            <a:off x="457200" y="2011680"/>
-            <a:ext cx="2011680" cy="3931920"/>
-          </a:xfrm>
-          <a:prstGeom prst="rect">
-            <a:avLst/>
-          </a:prstGeom>
-          <a:noFill/>
-        </p:spPr>
-        <p:txBody>
-          <a:bodyPr wrap="none">
-            <a:spAutoFit/>
-          </a:bodyPr>
-          <a:lstStyle/>
-          <a:p>
-            <a:pPr algn="l"/>
-            <a:r>
-              <a:rPr sz="1200" b="0">
-                <a:solidFill>
-                  <a:srgbClr val="181510"/>
-                </a:solidFill>
-                <a:latin typeface="Calibri"/>
-              </a:rPr>
-              <a:t>•  Expo boot + Hello ARCHIVE</a:t>
-            </a:r>
-          </a:p>
-          <a:p>
-            <a:pPr>
-              <a:spcBef>
-                <a:spcPts val="1200"/>
-              </a:spcBef>
-            </a:pPr>
-            <a:r>
-              <a:rPr sz="1200" b="0">
-                <a:solidFill>
-                  <a:srgbClr val="181510"/>
-                </a:solidFill>
-                <a:latin typeface="Calibri"/>
-              </a:rPr>
-              <a:t>•  Native / Hybrid / RN comparison</a:t>
-            </a:r>
-          </a:p>
-          <a:p>
-            <a:pPr>
-              <a:spcBef>
-                <a:spcPts val="1200"/>
-              </a:spcBef>
-            </a:pPr>
-            <a:r>
-              <a:rPr sz="1200" b="0">
-                <a:solidFill>
-                  <a:srgbClr val="181510"/>
-                </a:solidFill>
-                <a:latin typeface="Calibri"/>
-              </a:rPr>
-              <a:t>•  How we build screen</a:t>
-            </a:r>
-          </a:p>
-          <a:p>
-            <a:pPr>
-              <a:spcBef>
-                <a:spcPts val="1200"/>
-              </a:spcBef>
-            </a:pPr>
-            <a:r>
-              <a:rPr sz="1200" b="0">
-                <a:solidFill>
-                  <a:srgbClr val="181510"/>
-                </a:solidFill>
-                <a:latin typeface="Calibri"/>
-              </a:rPr>
-              <a:t>•  Pixel_9 Android target</a:t>
-            </a:r>
-          </a:p>
-        </p:txBody>
-      </p:sp>
-      <p:sp>
-        <p:nvSpPr>
-          <p:cNvPr id="8" name="Rounded Rectangle 7"/>
-          <p:cNvSpPr/>
-          <p:nvPr/>
-        </p:nvSpPr>
-        <p:spPr>
-          <a:xfrm>
-            <a:off x="2697479" y="1417320"/>
-            <a:ext cx="2194560" cy="4846320"/>
-          </a:xfrm>
-          <a:prstGeom prst="roundRect">
-            <a:avLst/>
-          </a:prstGeom>
-          <a:solidFill>
-            <a:srgbClr val="F6F2EA"/>
-          </a:solidFill>
-          <a:ln>
-            <a:solidFill>
-              <a:srgbClr val="C9C0B4"/>
-            </a:solidFill>
-          </a:ln>
-        </p:spPr>
-        <p:style>
-          <a:lnRef idx="1">
-            <a:schemeClr val="accent1"/>
-          </a:lnRef>
-          <a:fillRef idx="3">
-            <a:schemeClr val="accent1"/>
-          </a:fillRef>
-          <a:effectRef idx="2">
-            <a:schemeClr val="accent1"/>
-          </a:effectRef>
-          <a:fontRef idx="minor">
-            <a:schemeClr val="lt1"/>
-          </a:fontRef>
-        </p:style>
-        <p:txBody>
-          <a:bodyPr rtlCol="0" anchor="ctr"/>
-          <a:lstStyle/>
-          <a:p>
-            <a:pPr algn="ctr"/>
-          </a:p>
-        </p:txBody>
-      </p:sp>
-      <p:sp>
-        <p:nvSpPr>
-          <p:cNvPr id="9" name="TextBox 8"/>
-          <p:cNvSpPr txBox="1"/>
-          <p:nvPr/>
-        </p:nvSpPr>
-        <p:spPr>
-          <a:xfrm>
-            <a:off x="2807207" y="1554480"/>
-            <a:ext cx="1965960" cy="365760"/>
-          </a:xfrm>
-          <a:prstGeom prst="rect">
-            <a:avLst/>
-          </a:prstGeom>
-          <a:noFill/>
-        </p:spPr>
-        <p:txBody>
-          <a:bodyPr wrap="none">
-            <a:spAutoFit/>
-          </a:bodyPr>
-          <a:lstStyle/>
-          <a:p>
-            <a:pPr algn="l"/>
-            <a:r>
-              <a:rPr sz="1400" b="1">
-                <a:solidFill>
-                  <a:srgbClr val="A9522F"/>
-                </a:solidFill>
-                <a:latin typeface="Calibri"/>
-              </a:rPr>
-              <a:t>A3–A4</a:t>
-            </a:r>
-          </a:p>
-        </p:txBody>
-      </p:sp>
-      <p:sp>
-        <p:nvSpPr>
-          <p:cNvPr id="10" name="TextBox 9"/>
-          <p:cNvSpPr txBox="1"/>
-          <p:nvPr/>
-        </p:nvSpPr>
-        <p:spPr>
-          <a:xfrm>
-            <a:off x="2788919" y="2011680"/>
-            <a:ext cx="2011680" cy="3931920"/>
-          </a:xfrm>
-          <a:prstGeom prst="rect">
-            <a:avLst/>
-          </a:prstGeom>
-          <a:noFill/>
-        </p:spPr>
-        <p:txBody>
-          <a:bodyPr wrap="none">
-            <a:spAutoFit/>
-          </a:bodyPr>
-          <a:lstStyle/>
-          <a:p>
-            <a:pPr algn="l"/>
-            <a:r>
-              <a:rPr sz="1200" b="0">
-                <a:solidFill>
-                  <a:srgbClr val="181510"/>
-                </a:solidFill>
-                <a:latin typeface="Calibri"/>
-              </a:rPr>
-              <a:t>•  Reusable ProductCard props</a:t>
-            </a:r>
-          </a:p>
-          <a:p>
-            <a:pPr>
-              <a:spcBef>
-                <a:spcPts val="1200"/>
-              </a:spcBef>
-            </a:pPr>
-            <a:r>
-              <a:rPr sz="1200" b="0">
-                <a:solidFill>
-                  <a:srgbClr val="181510"/>
-                </a:solidFill>
-                <a:latin typeface="Calibri"/>
-              </a:rPr>
-              <a:t>•  Wishlist &amp; quantity state</a:t>
-            </a:r>
-          </a:p>
-          <a:p>
-            <a:pPr>
-              <a:spcBef>
-                <a:spcPts val="1200"/>
-              </a:spcBef>
-            </a:pPr>
-            <a:r>
-              <a:rPr sz="1200" b="0">
-                <a:solidFill>
-                  <a:srgbClr val="181510"/>
-                </a:solidFill>
-                <a:latin typeface="Calibri"/>
-              </a:rPr>
-              <a:t>•  Documented folders</a:t>
-            </a:r>
-          </a:p>
-          <a:p>
-            <a:pPr>
-              <a:spcBef>
-                <a:spcPts val="1200"/>
-              </a:spcBef>
-            </a:pPr>
-            <a:r>
-              <a:rPr sz="1200" b="0">
-                <a:solidFill>
-                  <a:srgbClr val="181510"/>
-                </a:solidFill>
-                <a:latin typeface="Calibri"/>
-              </a:rPr>
-              <a:t>•  Context reducers</a:t>
-            </a:r>
-          </a:p>
-        </p:txBody>
-      </p:sp>
-      <p:sp>
-        <p:nvSpPr>
-          <p:cNvPr id="11" name="Rounded Rectangle 10"/>
-          <p:cNvSpPr/>
-          <p:nvPr/>
-        </p:nvSpPr>
-        <p:spPr>
-          <a:xfrm>
-            <a:off x="5029200" y="1417320"/>
-            <a:ext cx="2194560" cy="4846320"/>
-          </a:xfrm>
-          <a:prstGeom prst="roundRect">
-            <a:avLst/>
-          </a:prstGeom>
-          <a:solidFill>
-            <a:srgbClr val="F6F2EA"/>
-          </a:solidFill>
-          <a:ln>
-            <a:solidFill>
-              <a:srgbClr val="C9C0B4"/>
-            </a:solidFill>
-          </a:ln>
-        </p:spPr>
-        <p:style>
-          <a:lnRef idx="1">
-            <a:schemeClr val="accent1"/>
-          </a:lnRef>
-          <a:fillRef idx="3">
-            <a:schemeClr val="accent1"/>
-          </a:fillRef>
-          <a:effectRef idx="2">
-            <a:schemeClr val="accent1"/>
-          </a:effectRef>
-          <a:fontRef idx="minor">
-            <a:schemeClr val="lt1"/>
-          </a:fontRef>
-        </p:style>
-        <p:txBody>
-          <a:bodyPr rtlCol="0" anchor="ctr"/>
-          <a:lstStyle/>
-          <a:p>
-            <a:pPr algn="ctr"/>
-          </a:p>
-        </p:txBody>
-      </p:sp>
-      <p:sp>
-        <p:nvSpPr>
-          <p:cNvPr id="12" name="TextBox 11"/>
-          <p:cNvSpPr txBox="1"/>
-          <p:nvPr/>
-        </p:nvSpPr>
-        <p:spPr>
-          <a:xfrm>
-            <a:off x="5138928" y="1554480"/>
-            <a:ext cx="1965960" cy="365760"/>
-          </a:xfrm>
-          <a:prstGeom prst="rect">
-            <a:avLst/>
-          </a:prstGeom>
-          <a:noFill/>
-        </p:spPr>
-        <p:txBody>
-          <a:bodyPr wrap="none">
-            <a:spAutoFit/>
-          </a:bodyPr>
-          <a:lstStyle/>
-          <a:p>
-            <a:pPr algn="l"/>
-            <a:r>
-              <a:rPr sz="1400" b="1">
-                <a:solidFill>
-                  <a:srgbClr val="A9522F"/>
-                </a:solidFill>
-                <a:latin typeface="Calibri"/>
-              </a:rPr>
-              <a:t>A5–A6</a:t>
-            </a:r>
-          </a:p>
-        </p:txBody>
-      </p:sp>
-      <p:sp>
-        <p:nvSpPr>
-          <p:cNvPr id="13" name="TextBox 12"/>
-          <p:cNvSpPr txBox="1"/>
-          <p:nvPr/>
-        </p:nvSpPr>
-        <p:spPr>
-          <a:xfrm>
-            <a:off x="5120640" y="2011680"/>
-            <a:ext cx="2011680" cy="3931920"/>
-          </a:xfrm>
-          <a:prstGeom prst="rect">
-            <a:avLst/>
-          </a:prstGeom>
-          <a:noFill/>
-        </p:spPr>
-        <p:txBody>
-          <a:bodyPr wrap="none">
-            <a:spAutoFit/>
-          </a:bodyPr>
-          <a:lstStyle/>
-          <a:p>
-            <a:pPr algn="l"/>
-            <a:r>
-              <a:rPr sz="1200" b="0">
-                <a:solidFill>
-                  <a:srgbClr val="181510"/>
-                </a:solidFill>
-                <a:latin typeface="Calibri"/>
-              </a:rPr>
-              <a:t>•  Profile core components</a:t>
-            </a:r>
-          </a:p>
-          <a:p>
-            <a:pPr>
-              <a:spcBef>
-                <a:spcPts val="1200"/>
-              </a:spcBef>
-            </a:pPr>
-            <a:r>
-              <a:rPr sz="1200" b="0">
-                <a:solidFill>
-                  <a:srgbClr val="181510"/>
-                </a:solidFill>
-                <a:latin typeface="Calibri"/>
-              </a:rPr>
-              <a:t>•  Nav list (not button soup)</a:t>
-            </a:r>
-          </a:p>
-          <a:p>
-            <a:pPr>
-              <a:spcBef>
-                <a:spcPts val="1200"/>
-              </a:spcBef>
-            </a:pPr>
-            <a:r>
-              <a:rPr sz="1200" b="0">
-                <a:solidFill>
-                  <a:srgbClr val="181510"/>
-                </a:solidFill>
-                <a:latin typeface="Calibri"/>
-              </a:rPr>
-              <a:t>•  Flexbox responsive UI</a:t>
-            </a:r>
-          </a:p>
-          <a:p>
-            <a:pPr>
-              <a:spcBef>
-                <a:spcPts val="1200"/>
-              </a:spcBef>
-            </a:pPr>
-            <a:r>
-              <a:rPr sz="1200" b="0">
-                <a:solidFill>
-                  <a:srgbClr val="181510"/>
-                </a:solidFill>
-                <a:latin typeface="Calibri"/>
-              </a:rPr>
-              <a:t>•  Validated forms + Alerts</a:t>
-            </a:r>
-          </a:p>
-        </p:txBody>
-      </p:sp>
-      <p:sp>
-        <p:nvSpPr>
-          <p:cNvPr id="14" name="Rounded Rectangle 13"/>
-          <p:cNvSpPr/>
-          <p:nvPr/>
-        </p:nvSpPr>
-        <p:spPr>
-          <a:xfrm>
-            <a:off x="7360919" y="1417320"/>
-            <a:ext cx="2194560" cy="4846320"/>
-          </a:xfrm>
-          <a:prstGeom prst="roundRect">
-            <a:avLst/>
-          </a:prstGeom>
-          <a:solidFill>
-            <a:srgbClr val="F6F2EA"/>
-          </a:solidFill>
-          <a:ln>
-            <a:solidFill>
-              <a:srgbClr val="C9C0B4"/>
-            </a:solidFill>
-          </a:ln>
-        </p:spPr>
-        <p:style>
-          <a:lnRef idx="1">
-            <a:schemeClr val="accent1"/>
-          </a:lnRef>
-          <a:fillRef idx="3">
-            <a:schemeClr val="accent1"/>
-          </a:fillRef>
-          <a:effectRef idx="2">
-            <a:schemeClr val="accent1"/>
-          </a:effectRef>
-          <a:fontRef idx="minor">
-            <a:schemeClr val="lt1"/>
-          </a:fontRef>
-        </p:style>
-        <p:txBody>
-          <a:bodyPr rtlCol="0" anchor="ctr"/>
-          <a:lstStyle/>
-          <a:p>
-            <a:pPr algn="ctr"/>
-          </a:p>
-        </p:txBody>
-      </p:sp>
-      <p:sp>
-        <p:nvSpPr>
-          <p:cNvPr id="15" name="TextBox 14"/>
-          <p:cNvSpPr txBox="1"/>
-          <p:nvPr/>
-        </p:nvSpPr>
-        <p:spPr>
-          <a:xfrm>
-            <a:off x="7470647" y="1554480"/>
-            <a:ext cx="1965960" cy="365760"/>
-          </a:xfrm>
-          <a:prstGeom prst="rect">
-            <a:avLst/>
-          </a:prstGeom>
-          <a:noFill/>
-        </p:spPr>
-        <p:txBody>
-          <a:bodyPr wrap="none">
-            <a:spAutoFit/>
-          </a:bodyPr>
-          <a:lstStyle/>
-          <a:p>
-            <a:pPr algn="l"/>
-            <a:r>
-              <a:rPr sz="1400" b="1">
-                <a:solidFill>
-                  <a:srgbClr val="A9522F"/>
-                </a:solidFill>
-                <a:latin typeface="Calibri"/>
-              </a:rPr>
-              <a:t>A7–A8</a:t>
-            </a:r>
-          </a:p>
-        </p:txBody>
-      </p:sp>
-      <p:sp>
-        <p:nvSpPr>
-          <p:cNvPr id="16" name="TextBox 15"/>
-          <p:cNvSpPr txBox="1"/>
-          <p:nvPr/>
-        </p:nvSpPr>
-        <p:spPr>
-          <a:xfrm>
-            <a:off x="7452359" y="2011680"/>
-            <a:ext cx="2011680" cy="3931920"/>
-          </a:xfrm>
-          <a:prstGeom prst="rect">
-            <a:avLst/>
-          </a:prstGeom>
-          <a:noFill/>
-        </p:spPr>
-        <p:txBody>
-          <a:bodyPr wrap="none">
-            <a:spAutoFit/>
-          </a:bodyPr>
-          <a:lstStyle/>
-          <a:p>
-            <a:pPr algn="l"/>
-            <a:r>
-              <a:rPr sz="1200" b="0">
-                <a:solidFill>
-                  <a:srgbClr val="181510"/>
-                </a:solidFill>
-                <a:latin typeface="Calibri"/>
-              </a:rPr>
-              <a:t>•  Stack + tab navigators</a:t>
-            </a:r>
-          </a:p>
-          <a:p>
-            <a:pPr>
-              <a:spcBef>
-                <a:spcPts val="1200"/>
-              </a:spcBef>
-            </a:pPr>
-            <a:r>
-              <a:rPr sz="1200" b="0">
-                <a:solidFill>
-                  <a:srgbClr val="181510"/>
-                </a:solidFill>
-                <a:latin typeface="Calibri"/>
-              </a:rPr>
-              <a:t>•  Typed route params</a:t>
-            </a:r>
-          </a:p>
-          <a:p>
-            <a:pPr>
-              <a:spcBef>
-                <a:spcPts val="1200"/>
-              </a:spcBef>
-            </a:pPr>
-            <a:r>
-              <a:rPr sz="1200" b="0">
-                <a:solidFill>
-                  <a:srgbClr val="181510"/>
-                </a:solidFill>
-                <a:latin typeface="Calibri"/>
-              </a:rPr>
-              <a:t>•  Local JSON FlatList</a:t>
-            </a:r>
-          </a:p>
-          <a:p>
-            <a:pPr>
-              <a:spcBef>
-                <a:spcPts val="1200"/>
-              </a:spcBef>
-            </a:pPr>
-            <a:r>
-              <a:rPr sz="1200" b="0">
-                <a:solidFill>
-                  <a:srgbClr val="181510"/>
-                </a:solidFill>
-                <a:latin typeface="Calibri"/>
-              </a:rPr>
-              <a:t>•  Public API Discover more</a:t>
-            </a:r>
-          </a:p>
-        </p:txBody>
-      </p:sp>
-      <p:sp>
-        <p:nvSpPr>
-          <p:cNvPr id="17" name="Rounded Rectangle 16"/>
-          <p:cNvSpPr/>
-          <p:nvPr/>
-        </p:nvSpPr>
-        <p:spPr>
-          <a:xfrm>
-            <a:off x="9692640" y="1417320"/>
-            <a:ext cx="2194560" cy="4846320"/>
-          </a:xfrm>
-          <a:prstGeom prst="roundRect">
-            <a:avLst/>
-          </a:prstGeom>
-          <a:solidFill>
-            <a:srgbClr val="F6F2EA"/>
-          </a:solidFill>
-          <a:ln>
-            <a:solidFill>
-              <a:srgbClr val="C9C0B4"/>
-            </a:solidFill>
-          </a:ln>
-        </p:spPr>
-        <p:style>
-          <a:lnRef idx="1">
-            <a:schemeClr val="accent1"/>
-          </a:lnRef>
-          <a:fillRef idx="3">
-            <a:schemeClr val="accent1"/>
-          </a:fillRef>
-          <a:effectRef idx="2">
-            <a:schemeClr val="accent1"/>
-          </a:effectRef>
-          <a:fontRef idx="minor">
-            <a:schemeClr val="lt1"/>
-          </a:fontRef>
-        </p:style>
-        <p:txBody>
-          <a:bodyPr rtlCol="0" anchor="ctr"/>
-          <a:lstStyle/>
-          <a:p>
-            <a:pPr algn="ctr"/>
-          </a:p>
-        </p:txBody>
-      </p:sp>
-      <p:sp>
-        <p:nvSpPr>
-          <p:cNvPr id="18" name="TextBox 17"/>
-          <p:cNvSpPr txBox="1"/>
-          <p:nvPr/>
-        </p:nvSpPr>
-        <p:spPr>
-          <a:xfrm>
-            <a:off x="9802368" y="1554480"/>
-            <a:ext cx="1965960" cy="365760"/>
-          </a:xfrm>
-          <a:prstGeom prst="rect">
-            <a:avLst/>
-          </a:prstGeom>
-          <a:noFill/>
-        </p:spPr>
-        <p:txBody>
-          <a:bodyPr wrap="none">
-            <a:spAutoFit/>
-          </a:bodyPr>
-          <a:lstStyle/>
-          <a:p>
-            <a:pPr algn="l"/>
-            <a:r>
-              <a:rPr sz="1400" b="1">
-                <a:solidFill>
-                  <a:srgbClr val="A9522F"/>
-                </a:solidFill>
-                <a:latin typeface="Calibri"/>
-              </a:rPr>
-              <a:t>A9–A10</a:t>
-            </a:r>
-          </a:p>
-        </p:txBody>
-      </p:sp>
-      <p:sp>
-        <p:nvSpPr>
-          <p:cNvPr id="19" name="TextBox 18"/>
-          <p:cNvSpPr txBox="1"/>
-          <p:nvPr/>
-        </p:nvSpPr>
-        <p:spPr>
-          <a:xfrm>
-            <a:off x="9784080" y="2011680"/>
-            <a:ext cx="2011680" cy="3931920"/>
-          </a:xfrm>
-          <a:prstGeom prst="rect">
-            <a:avLst/>
-          </a:prstGeom>
-          <a:noFill/>
-        </p:spPr>
-        <p:txBody>
-          <a:bodyPr wrap="none">
-            <a:spAutoFit/>
-          </a:bodyPr>
-          <a:lstStyle/>
-          <a:p>
-            <a:pPr algn="l"/>
-            <a:r>
-              <a:rPr sz="1200" b="0">
-                <a:solidFill>
-                  <a:srgbClr val="181510"/>
-                </a:solidFill>
-                <a:latin typeface="Calibri"/>
-              </a:rPr>
-              <a:t>•  Full storefront pages</a:t>
-            </a:r>
-          </a:p>
-          <a:p>
-            <a:pPr>
-              <a:spcBef>
-                <a:spcPts val="1200"/>
-              </a:spcBef>
-            </a:pPr>
-            <a:r>
-              <a:rPr sz="1200" b="0">
-                <a:solidFill>
-                  <a:srgbClr val="181510"/>
-                </a:solidFill>
-                <a:latin typeface="Calibri"/>
-              </a:rPr>
-              <a:t>•  Search / filter / sort</a:t>
-            </a:r>
-          </a:p>
-          <a:p>
-            <a:pPr>
-              <a:spcBef>
-                <a:spcPts val="1200"/>
-              </a:spcBef>
-            </a:pPr>
-            <a:r>
-              <a:rPr sz="1200" b="0">
-                <a:solidFill>
-                  <a:srgbClr val="181510"/>
-                </a:solidFill>
-                <a:latin typeface="Calibri"/>
-              </a:rPr>
-              <a:t>•  Cart persistence</a:t>
-            </a:r>
-          </a:p>
-          <a:p>
-            <a:pPr>
-              <a:spcBef>
-                <a:spcPts val="1200"/>
-              </a:spcBef>
-            </a:pPr>
-            <a:r>
-              <a:rPr sz="1200" b="0">
-                <a:solidFill>
-                  <a:srgbClr val="181510"/>
-                </a:solidFill>
-                <a:latin typeface="Calibri"/>
-              </a:rPr>
-              <a:t>•  Checkout → confirmation</a:t>
-            </a:r>
-          </a:p>
-        </p:txBody>
-      </p:sp>
-    </p:spTree>
-  </p:cSld>
-  <p:clrMapOvr>
-    <a:masterClrMapping/>
-  </p:clrMapOvr>
-</p:sld>
-</file>
-
 <file path=ppt/slides/slide22.xml><?xml version="1.0" encoding="utf-8"?>
 <p:sld xmlns:a="http://schemas.openxmlformats.org/drawingml/2006/main" xmlns:p="http://schemas.openxmlformats.org/presentationml/2006/main" xmlns:r="http://schemas.openxmlformats.org/officeDocument/2006/relationships">
   <p:cSld>
@@ -8115,7 +7349,7 @@
                 </a:solidFill>
                 <a:latin typeface="Calibri"/>
               </a:rPr>
-              <a:t>Live demo script (~2 min)</a:t>
+              <a:t>Assignment highlights</a:t>
             </a:r>
           </a:p>
         </p:txBody>
@@ -8193,21 +7427,66 @@
                 </a:solidFill>
                 <a:latin typeface="Calibri"/>
               </a:rPr>
-              <a:t>Suggested viva walkthrough on Pixel_9</a:t>
-            </a:r>
-          </a:p>
-        </p:txBody>
-      </p:sp>
-      <p:sp>
-        <p:nvSpPr>
-          <p:cNvPr id="5" name="TextBox 4"/>
+              <a:t>Concept → product surface</a:t>
+            </a:r>
+          </a:p>
+        </p:txBody>
+      </p:sp>
+      <p:sp>
+        <p:nvSpPr>
+          <p:cNvPr id="5" name="Rounded Rectangle 4"/>
+          <p:cNvSpPr/>
+          <p:nvPr/>
+        </p:nvSpPr>
+        <p:spPr>
+          <a:xfrm>
+            <a:off x="365760" y="1417320"/>
+            <a:ext cx="2194560" cy="4846320"/>
+          </a:xfrm>
+          <a:prstGeom prst="roundRect">
+            <a:avLst/>
+          </a:prstGeom>
+          <a:solidFill>
+            <a:srgbClr val="F6F2EA"/>
+          </a:solidFill>
+          <a:ln>
+            <a:solidFill>
+              <a:srgbClr val="C9C0B4"/>
+            </a:solidFill>
+          </a:ln>
+        </p:spPr>
+        <p:style>
+          <a:lnRef idx="1">
+            <a:schemeClr val="accent1"/>
+          </a:lnRef>
+          <a:fillRef idx="3">
+            <a:schemeClr val="accent1"/>
+          </a:fillRef>
+          <a:effectRef idx="2">
+            <a:schemeClr val="accent1"/>
+          </a:effectRef>
+          <a:fontRef idx="minor">
+            <a:schemeClr val="lt1"/>
+          </a:fontRef>
+        </p:style>
+        <p:txBody>
+          <a:bodyPr rtlCol="0" anchor="ctr"/>
+          <a:lstStyle/>
+          <a:p>
+            <a:pPr algn="ctr"/>
+          </a:p>
+        </p:txBody>
+      </p:sp>
+      <p:sp>
+        <p:nvSpPr>
+          <p:cNvPr id="6" name="TextBox 5"/>
           <p:cNvSpPr txBox="1"/>
           <p:nvPr/>
         </p:nvSpPr>
         <p:spPr>
           <a:xfrm>
-            <a:off x="548640" y="1554480"/>
-            <a:ext cx="6400800" cy="4572000"/>
+            <a:off x="475488" y="1554480"/>
+            <a:ext cx="1965960" cy="365760"/>
           </a:xfrm>
           <a:prstGeom prst="rect">
             <a:avLst/>
@@ -8222,13 +7501,48 @@
           <a:p>
             <a:pPr algn="l"/>
             <a:r>
-              <a:rPr sz="1700" b="0">
-                <a:solidFill>
-                  <a:srgbClr val="181510"/>
-                </a:solidFill>
-                <a:latin typeface="Calibri"/>
-              </a:rPr>
-              <a:t>•  Boot Hello ARCHIVE → Enter</a:t>
+              <a:rPr sz="1400" b="1">
+                <a:solidFill>
+                  <a:srgbClr val="A9522F"/>
+                </a:solidFill>
+                <a:latin typeface="Calibri"/>
+              </a:rPr>
+              <a:t>A1–A2</a:t>
+            </a:r>
+          </a:p>
+        </p:txBody>
+      </p:sp>
+      <p:sp>
+        <p:nvSpPr>
+          <p:cNvPr id="7" name="TextBox 6"/>
+          <p:cNvSpPr txBox="1"/>
+          <p:nvPr/>
+        </p:nvSpPr>
+        <p:spPr>
+          <a:xfrm>
+            <a:off x="457200" y="2011680"/>
+            <a:ext cx="2011680" cy="3931920"/>
+          </a:xfrm>
+          <a:prstGeom prst="rect">
+            <a:avLst/>
+          </a:prstGeom>
+          <a:noFill/>
+        </p:spPr>
+        <p:txBody>
+          <a:bodyPr wrap="none">
+            <a:spAutoFit/>
+          </a:bodyPr>
+          <a:lstStyle/>
+          <a:p>
+            <a:pPr algn="l"/>
+            <a:r>
+              <a:rPr sz="1200" b="0">
+                <a:solidFill>
+                  <a:srgbClr val="181510"/>
+                </a:solidFill>
+                <a:latin typeface="Calibri"/>
+              </a:rPr>
+              <a:t>•  Expo boot + Hello ARCHIVE</a:t>
             </a:r>
           </a:p>
           <a:p>
@@ -8238,13 +7552,13 @@
               </a:spcBef>
             </a:pPr>
             <a:r>
-              <a:rPr sz="1700" b="0">
-                <a:solidFill>
-                  <a:srgbClr val="181510"/>
-                </a:solidFill>
-                <a:latin typeface="Calibri"/>
-              </a:rPr>
-              <a:t>•  Home hero scroll → Shop the Archive</a:t>
+              <a:rPr sz="1200" b="0">
+                <a:solidFill>
+                  <a:srgbClr val="181510"/>
+                </a:solidFill>
+                <a:latin typeface="Calibri"/>
+              </a:rPr>
+              <a:t>•  Native / Hybrid / RN comparison</a:t>
             </a:r>
           </a:p>
           <a:p>
@@ -8254,13 +7568,13 @@
               </a:spcBef>
             </a:pPr>
             <a:r>
-              <a:rPr sz="1700" b="0">
-                <a:solidFill>
-                  <a:srgbClr val="181510"/>
-                </a:solidFill>
-                <a:latin typeface="Calibri"/>
-              </a:rPr>
-              <a:t>•  Filter catalogue → open a piece → wishlist → add to cart</a:t>
+              <a:rPr sz="1200" b="0">
+                <a:solidFill>
+                  <a:srgbClr val="181510"/>
+                </a:solidFill>
+                <a:latin typeface="Calibri"/>
+              </a:rPr>
+              <a:t>•  How we build screen</a:t>
             </a:r>
           </a:p>
           <a:p>
@@ -8270,13 +7584,128 @@
               </a:spcBef>
             </a:pPr>
             <a:r>
-              <a:rPr sz="1700" b="0">
-                <a:solidFill>
-                  <a:srgbClr val="181510"/>
-                </a:solidFill>
-                <a:latin typeface="Calibri"/>
-              </a:rPr>
-              <a:t>•  Cart qty → Checkout → place order → confirmation</a:t>
+              <a:rPr sz="1200" b="0">
+                <a:solidFill>
+                  <a:srgbClr val="181510"/>
+                </a:solidFill>
+                <a:latin typeface="Calibri"/>
+              </a:rPr>
+              <a:t>•  Pixel_9 Android target</a:t>
+            </a:r>
+          </a:p>
+        </p:txBody>
+      </p:sp>
+      <p:sp>
+        <p:nvSpPr>
+          <p:cNvPr id="8" name="Rounded Rectangle 7"/>
+          <p:cNvSpPr/>
+          <p:nvPr/>
+        </p:nvSpPr>
+        <p:spPr>
+          <a:xfrm>
+            <a:off x="2697479" y="1417320"/>
+            <a:ext cx="2194560" cy="4846320"/>
+          </a:xfrm>
+          <a:prstGeom prst="roundRect">
+            <a:avLst/>
+          </a:prstGeom>
+          <a:solidFill>
+            <a:srgbClr val="F6F2EA"/>
+          </a:solidFill>
+          <a:ln>
+            <a:solidFill>
+              <a:srgbClr val="C9C0B4"/>
+            </a:solidFill>
+          </a:ln>
+        </p:spPr>
+        <p:style>
+          <a:lnRef idx="1">
+            <a:schemeClr val="accent1"/>
+          </a:lnRef>
+          <a:fillRef idx="3">
+            <a:schemeClr val="accent1"/>
+          </a:fillRef>
+          <a:effectRef idx="2">
+            <a:schemeClr val="accent1"/>
+          </a:effectRef>
+          <a:fontRef idx="minor">
+            <a:schemeClr val="lt1"/>
+          </a:fontRef>
+        </p:style>
+        <p:txBody>
+          <a:bodyPr rtlCol="0" anchor="ctr"/>
+          <a:lstStyle/>
+          <a:p>
+            <a:pPr algn="ctr"/>
+          </a:p>
+        </p:txBody>
+      </p:sp>
+      <p:sp>
+        <p:nvSpPr>
+          <p:cNvPr id="9" name="TextBox 8"/>
+          <p:cNvSpPr txBox="1"/>
+          <p:nvPr/>
+        </p:nvSpPr>
+        <p:spPr>
+          <a:xfrm>
+            <a:off x="2807207" y="1554480"/>
+            <a:ext cx="1965960" cy="365760"/>
+          </a:xfrm>
+          <a:prstGeom prst="rect">
+            <a:avLst/>
+          </a:prstGeom>
+          <a:noFill/>
+        </p:spPr>
+        <p:txBody>
+          <a:bodyPr wrap="none">
+            <a:spAutoFit/>
+          </a:bodyPr>
+          <a:lstStyle/>
+          <a:p>
+            <a:pPr algn="l"/>
+            <a:r>
+              <a:rPr sz="1400" b="1">
+                <a:solidFill>
+                  <a:srgbClr val="A9522F"/>
+                </a:solidFill>
+                <a:latin typeface="Calibri"/>
+              </a:rPr>
+              <a:t>A3–A4</a:t>
+            </a:r>
+          </a:p>
+        </p:txBody>
+      </p:sp>
+      <p:sp>
+        <p:nvSpPr>
+          <p:cNvPr id="10" name="TextBox 9"/>
+          <p:cNvSpPr txBox="1"/>
+          <p:nvPr/>
+        </p:nvSpPr>
+        <p:spPr>
+          <a:xfrm>
+            <a:off x="2788919" y="2011680"/>
+            <a:ext cx="2011680" cy="3931920"/>
+          </a:xfrm>
+          <a:prstGeom prst="rect">
+            <a:avLst/>
+          </a:prstGeom>
+          <a:noFill/>
+        </p:spPr>
+        <p:txBody>
+          <a:bodyPr wrap="none">
+            <a:spAutoFit/>
+          </a:bodyPr>
+          <a:lstStyle/>
+          <a:p>
+            <a:pPr algn="l"/>
+            <a:r>
+              <a:rPr sz="1200" b="0">
+                <a:solidFill>
+                  <a:srgbClr val="181510"/>
+                </a:solidFill>
+                <a:latin typeface="Calibri"/>
+              </a:rPr>
+              <a:t>•  Reusable ProductCard props</a:t>
             </a:r>
           </a:p>
           <a:p>
@@ -8286,13 +7715,13 @@
               </a:spcBef>
             </a:pPr>
             <a:r>
-              <a:rPr sz="1700" b="0">
-                <a:solidFill>
-                  <a:srgbClr val="181510"/>
-                </a:solidFill>
-                <a:latin typeface="Calibri"/>
-              </a:rPr>
-              <a:t>•  Profile → Orders / How we build / Discover more</a:t>
+              <a:rPr sz="1200" b="0">
+                <a:solidFill>
+                  <a:srgbClr val="181510"/>
+                </a:solidFill>
+                <a:latin typeface="Calibri"/>
+              </a:rPr>
+              <a:t>•  Wishlist &amp; quantity state</a:t>
             </a:r>
           </a:p>
           <a:p>
@@ -8302,41 +7731,522 @@
               </a:spcBef>
             </a:pPr>
             <a:r>
-              <a:rPr sz="1700" b="0">
-                <a:solidFill>
-                  <a:srgbClr val="181510"/>
-                </a:solidFill>
-                <a:latin typeface="Calibri"/>
-              </a:rPr>
-              <a:t>•  Mention INR catalogue + AsyncStorage persistence</a:t>
-            </a:r>
-          </a:p>
-        </p:txBody>
-      </p:sp>
-      <p:pic>
-        <p:nvPicPr>
-          <p:cNvPr id="6" name="Picture 5" descr="01_hello.png"/>
-          <p:cNvPicPr>
-            <a:picLocks noChangeAspect="1"/>
-          </p:cNvPicPr>
-          <p:nvPr/>
-        </p:nvPicPr>
-        <p:blipFill>
-          <a:blip r:embed="rId2"/>
-          <a:stretch>
-            <a:fillRect/>
-          </a:stretch>
-        </p:blipFill>
-        <p:spPr>
-          <a:xfrm>
-            <a:off x="7498079" y="1280160"/>
-            <a:ext cx="2323919" cy="5029200"/>
-          </a:xfrm>
-          <a:prstGeom prst="rect">
-            <a:avLst/>
-          </a:prstGeom>
-        </p:spPr>
-      </p:pic>
+              <a:rPr sz="1200" b="0">
+                <a:solidFill>
+                  <a:srgbClr val="181510"/>
+                </a:solidFill>
+                <a:latin typeface="Calibri"/>
+              </a:rPr>
+              <a:t>•  Documented folders</a:t>
+            </a:r>
+          </a:p>
+          <a:p>
+            <a:pPr>
+              <a:spcBef>
+                <a:spcPts val="1200"/>
+              </a:spcBef>
+            </a:pPr>
+            <a:r>
+              <a:rPr sz="1200" b="0">
+                <a:solidFill>
+                  <a:srgbClr val="181510"/>
+                </a:solidFill>
+                <a:latin typeface="Calibri"/>
+              </a:rPr>
+              <a:t>•  Context reducers</a:t>
+            </a:r>
+          </a:p>
+        </p:txBody>
+      </p:sp>
+      <p:sp>
+        <p:nvSpPr>
+          <p:cNvPr id="11" name="Rounded Rectangle 10"/>
+          <p:cNvSpPr/>
+          <p:nvPr/>
+        </p:nvSpPr>
+        <p:spPr>
+          <a:xfrm>
+            <a:off x="5029200" y="1417320"/>
+            <a:ext cx="2194560" cy="4846320"/>
+          </a:xfrm>
+          <a:prstGeom prst="roundRect">
+            <a:avLst/>
+          </a:prstGeom>
+          <a:solidFill>
+            <a:srgbClr val="F6F2EA"/>
+          </a:solidFill>
+          <a:ln>
+            <a:solidFill>
+              <a:srgbClr val="C9C0B4"/>
+            </a:solidFill>
+          </a:ln>
+        </p:spPr>
+        <p:style>
+          <a:lnRef idx="1">
+            <a:schemeClr val="accent1"/>
+          </a:lnRef>
+          <a:fillRef idx="3">
+            <a:schemeClr val="accent1"/>
+          </a:fillRef>
+          <a:effectRef idx="2">
+            <a:schemeClr val="accent1"/>
+          </a:effectRef>
+          <a:fontRef idx="minor">
+            <a:schemeClr val="lt1"/>
+          </a:fontRef>
+        </p:style>
+        <p:txBody>
+          <a:bodyPr rtlCol="0" anchor="ctr"/>
+          <a:lstStyle/>
+          <a:p>
+            <a:pPr algn="ctr"/>
+          </a:p>
+        </p:txBody>
+      </p:sp>
+      <p:sp>
+        <p:nvSpPr>
+          <p:cNvPr id="12" name="TextBox 11"/>
+          <p:cNvSpPr txBox="1"/>
+          <p:nvPr/>
+        </p:nvSpPr>
+        <p:spPr>
+          <a:xfrm>
+            <a:off x="5138928" y="1554480"/>
+            <a:ext cx="1965960" cy="365760"/>
+          </a:xfrm>
+          <a:prstGeom prst="rect">
+            <a:avLst/>
+          </a:prstGeom>
+          <a:noFill/>
+        </p:spPr>
+        <p:txBody>
+          <a:bodyPr wrap="none">
+            <a:spAutoFit/>
+          </a:bodyPr>
+          <a:lstStyle/>
+          <a:p>
+            <a:pPr algn="l"/>
+            <a:r>
+              <a:rPr sz="1400" b="1">
+                <a:solidFill>
+                  <a:srgbClr val="A9522F"/>
+                </a:solidFill>
+                <a:latin typeface="Calibri"/>
+              </a:rPr>
+              <a:t>A5–A6</a:t>
+            </a:r>
+          </a:p>
+        </p:txBody>
+      </p:sp>
+      <p:sp>
+        <p:nvSpPr>
+          <p:cNvPr id="13" name="TextBox 12"/>
+          <p:cNvSpPr txBox="1"/>
+          <p:nvPr/>
+        </p:nvSpPr>
+        <p:spPr>
+          <a:xfrm>
+            <a:off x="5120640" y="2011680"/>
+            <a:ext cx="2011680" cy="3931920"/>
+          </a:xfrm>
+          <a:prstGeom prst="rect">
+            <a:avLst/>
+          </a:prstGeom>
+          <a:noFill/>
+        </p:spPr>
+        <p:txBody>
+          <a:bodyPr wrap="none">
+            <a:spAutoFit/>
+          </a:bodyPr>
+          <a:lstStyle/>
+          <a:p>
+            <a:pPr algn="l"/>
+            <a:r>
+              <a:rPr sz="1200" b="0">
+                <a:solidFill>
+                  <a:srgbClr val="181510"/>
+                </a:solidFill>
+                <a:latin typeface="Calibri"/>
+              </a:rPr>
+              <a:t>•  Profile core components</a:t>
+            </a:r>
+          </a:p>
+          <a:p>
+            <a:pPr>
+              <a:spcBef>
+                <a:spcPts val="1200"/>
+              </a:spcBef>
+            </a:pPr>
+            <a:r>
+              <a:rPr sz="1200" b="0">
+                <a:solidFill>
+                  <a:srgbClr val="181510"/>
+                </a:solidFill>
+                <a:latin typeface="Calibri"/>
+              </a:rPr>
+              <a:t>•  Nav list (not button soup)</a:t>
+            </a:r>
+          </a:p>
+          <a:p>
+            <a:pPr>
+              <a:spcBef>
+                <a:spcPts val="1200"/>
+              </a:spcBef>
+            </a:pPr>
+            <a:r>
+              <a:rPr sz="1200" b="0">
+                <a:solidFill>
+                  <a:srgbClr val="181510"/>
+                </a:solidFill>
+                <a:latin typeface="Calibri"/>
+              </a:rPr>
+              <a:t>•  Flexbox responsive UI</a:t>
+            </a:r>
+          </a:p>
+          <a:p>
+            <a:pPr>
+              <a:spcBef>
+                <a:spcPts val="1200"/>
+              </a:spcBef>
+            </a:pPr>
+            <a:r>
+              <a:rPr sz="1200" b="0">
+                <a:solidFill>
+                  <a:srgbClr val="181510"/>
+                </a:solidFill>
+                <a:latin typeface="Calibri"/>
+              </a:rPr>
+              <a:t>•  Validated forms + Alerts</a:t>
+            </a:r>
+          </a:p>
+        </p:txBody>
+      </p:sp>
+      <p:sp>
+        <p:nvSpPr>
+          <p:cNvPr id="14" name="Rounded Rectangle 13"/>
+          <p:cNvSpPr/>
+          <p:nvPr/>
+        </p:nvSpPr>
+        <p:spPr>
+          <a:xfrm>
+            <a:off x="7360919" y="1417320"/>
+            <a:ext cx="2194560" cy="4846320"/>
+          </a:xfrm>
+          <a:prstGeom prst="roundRect">
+            <a:avLst/>
+          </a:prstGeom>
+          <a:solidFill>
+            <a:srgbClr val="F6F2EA"/>
+          </a:solidFill>
+          <a:ln>
+            <a:solidFill>
+              <a:srgbClr val="C9C0B4"/>
+            </a:solidFill>
+          </a:ln>
+        </p:spPr>
+        <p:style>
+          <a:lnRef idx="1">
+            <a:schemeClr val="accent1"/>
+          </a:lnRef>
+          <a:fillRef idx="3">
+            <a:schemeClr val="accent1"/>
+          </a:fillRef>
+          <a:effectRef idx="2">
+            <a:schemeClr val="accent1"/>
+          </a:effectRef>
+          <a:fontRef idx="minor">
+            <a:schemeClr val="lt1"/>
+          </a:fontRef>
+        </p:style>
+        <p:txBody>
+          <a:bodyPr rtlCol="0" anchor="ctr"/>
+          <a:lstStyle/>
+          <a:p>
+            <a:pPr algn="ctr"/>
+          </a:p>
+        </p:txBody>
+      </p:sp>
+      <p:sp>
+        <p:nvSpPr>
+          <p:cNvPr id="15" name="TextBox 14"/>
+          <p:cNvSpPr txBox="1"/>
+          <p:nvPr/>
+        </p:nvSpPr>
+        <p:spPr>
+          <a:xfrm>
+            <a:off x="7470647" y="1554480"/>
+            <a:ext cx="1965960" cy="365760"/>
+          </a:xfrm>
+          <a:prstGeom prst="rect">
+            <a:avLst/>
+          </a:prstGeom>
+          <a:noFill/>
+        </p:spPr>
+        <p:txBody>
+          <a:bodyPr wrap="none">
+            <a:spAutoFit/>
+          </a:bodyPr>
+          <a:lstStyle/>
+          <a:p>
+            <a:pPr algn="l"/>
+            <a:r>
+              <a:rPr sz="1400" b="1">
+                <a:solidFill>
+                  <a:srgbClr val="A9522F"/>
+                </a:solidFill>
+                <a:latin typeface="Calibri"/>
+              </a:rPr>
+              <a:t>A7–A8</a:t>
+            </a:r>
+          </a:p>
+        </p:txBody>
+      </p:sp>
+      <p:sp>
+        <p:nvSpPr>
+          <p:cNvPr id="16" name="TextBox 15"/>
+          <p:cNvSpPr txBox="1"/>
+          <p:nvPr/>
+        </p:nvSpPr>
+        <p:spPr>
+          <a:xfrm>
+            <a:off x="7452359" y="2011680"/>
+            <a:ext cx="2011680" cy="3931920"/>
+          </a:xfrm>
+          <a:prstGeom prst="rect">
+            <a:avLst/>
+          </a:prstGeom>
+          <a:noFill/>
+        </p:spPr>
+        <p:txBody>
+          <a:bodyPr wrap="none">
+            <a:spAutoFit/>
+          </a:bodyPr>
+          <a:lstStyle/>
+          <a:p>
+            <a:pPr algn="l"/>
+            <a:r>
+              <a:rPr sz="1200" b="0">
+                <a:solidFill>
+                  <a:srgbClr val="181510"/>
+                </a:solidFill>
+                <a:latin typeface="Calibri"/>
+              </a:rPr>
+              <a:t>•  Stack + tab navigators</a:t>
+            </a:r>
+          </a:p>
+          <a:p>
+            <a:pPr>
+              <a:spcBef>
+                <a:spcPts val="1200"/>
+              </a:spcBef>
+            </a:pPr>
+            <a:r>
+              <a:rPr sz="1200" b="0">
+                <a:solidFill>
+                  <a:srgbClr val="181510"/>
+                </a:solidFill>
+                <a:latin typeface="Calibri"/>
+              </a:rPr>
+              <a:t>•  Typed route params</a:t>
+            </a:r>
+          </a:p>
+          <a:p>
+            <a:pPr>
+              <a:spcBef>
+                <a:spcPts val="1200"/>
+              </a:spcBef>
+            </a:pPr>
+            <a:r>
+              <a:rPr sz="1200" b="0">
+                <a:solidFill>
+                  <a:srgbClr val="181510"/>
+                </a:solidFill>
+                <a:latin typeface="Calibri"/>
+              </a:rPr>
+              <a:t>•  Local JSON FlatList</a:t>
+            </a:r>
+          </a:p>
+          <a:p>
+            <a:pPr>
+              <a:spcBef>
+                <a:spcPts val="1200"/>
+              </a:spcBef>
+            </a:pPr>
+            <a:r>
+              <a:rPr sz="1200" b="0">
+                <a:solidFill>
+                  <a:srgbClr val="181510"/>
+                </a:solidFill>
+                <a:latin typeface="Calibri"/>
+              </a:rPr>
+              <a:t>•  Public API Discover more</a:t>
+            </a:r>
+          </a:p>
+        </p:txBody>
+      </p:sp>
+      <p:sp>
+        <p:nvSpPr>
+          <p:cNvPr id="17" name="Rounded Rectangle 16"/>
+          <p:cNvSpPr/>
+          <p:nvPr/>
+        </p:nvSpPr>
+        <p:spPr>
+          <a:xfrm>
+            <a:off x="9692640" y="1417320"/>
+            <a:ext cx="2194560" cy="4846320"/>
+          </a:xfrm>
+          <a:prstGeom prst="roundRect">
+            <a:avLst/>
+          </a:prstGeom>
+          <a:solidFill>
+            <a:srgbClr val="F6F2EA"/>
+          </a:solidFill>
+          <a:ln>
+            <a:solidFill>
+              <a:srgbClr val="C9C0B4"/>
+            </a:solidFill>
+          </a:ln>
+        </p:spPr>
+        <p:style>
+          <a:lnRef idx="1">
+            <a:schemeClr val="accent1"/>
+          </a:lnRef>
+          <a:fillRef idx="3">
+            <a:schemeClr val="accent1"/>
+          </a:fillRef>
+          <a:effectRef idx="2">
+            <a:schemeClr val="accent1"/>
+          </a:effectRef>
+          <a:fontRef idx="minor">
+            <a:schemeClr val="lt1"/>
+          </a:fontRef>
+        </p:style>
+        <p:txBody>
+          <a:bodyPr rtlCol="0" anchor="ctr"/>
+          <a:lstStyle/>
+          <a:p>
+            <a:pPr algn="ctr"/>
+          </a:p>
+        </p:txBody>
+      </p:sp>
+      <p:sp>
+        <p:nvSpPr>
+          <p:cNvPr id="18" name="TextBox 17"/>
+          <p:cNvSpPr txBox="1"/>
+          <p:nvPr/>
+        </p:nvSpPr>
+        <p:spPr>
+          <a:xfrm>
+            <a:off x="9802368" y="1554480"/>
+            <a:ext cx="1965960" cy="365760"/>
+          </a:xfrm>
+          <a:prstGeom prst="rect">
+            <a:avLst/>
+          </a:prstGeom>
+          <a:noFill/>
+        </p:spPr>
+        <p:txBody>
+          <a:bodyPr wrap="none">
+            <a:spAutoFit/>
+          </a:bodyPr>
+          <a:lstStyle/>
+          <a:p>
+            <a:pPr algn="l"/>
+            <a:r>
+              <a:rPr sz="1400" b="1">
+                <a:solidFill>
+                  <a:srgbClr val="A9522F"/>
+                </a:solidFill>
+                <a:latin typeface="Calibri"/>
+              </a:rPr>
+              <a:t>A9–A10</a:t>
+            </a:r>
+          </a:p>
+        </p:txBody>
+      </p:sp>
+      <p:sp>
+        <p:nvSpPr>
+          <p:cNvPr id="19" name="TextBox 18"/>
+          <p:cNvSpPr txBox="1"/>
+          <p:nvPr/>
+        </p:nvSpPr>
+        <p:spPr>
+          <a:xfrm>
+            <a:off x="9784080" y="2011680"/>
+            <a:ext cx="2011680" cy="3931920"/>
+          </a:xfrm>
+          <a:prstGeom prst="rect">
+            <a:avLst/>
+          </a:prstGeom>
+          <a:noFill/>
+        </p:spPr>
+        <p:txBody>
+          <a:bodyPr wrap="none">
+            <a:spAutoFit/>
+          </a:bodyPr>
+          <a:lstStyle/>
+          <a:p>
+            <a:pPr algn="l"/>
+            <a:r>
+              <a:rPr sz="1200" b="0">
+                <a:solidFill>
+                  <a:srgbClr val="181510"/>
+                </a:solidFill>
+                <a:latin typeface="Calibri"/>
+              </a:rPr>
+              <a:t>•  Full storefront pages</a:t>
+            </a:r>
+          </a:p>
+          <a:p>
+            <a:pPr>
+              <a:spcBef>
+                <a:spcPts val="1200"/>
+              </a:spcBef>
+            </a:pPr>
+            <a:r>
+              <a:rPr sz="1200" b="0">
+                <a:solidFill>
+                  <a:srgbClr val="181510"/>
+                </a:solidFill>
+                <a:latin typeface="Calibri"/>
+              </a:rPr>
+              <a:t>•  Search / filter / sort</a:t>
+            </a:r>
+          </a:p>
+          <a:p>
+            <a:pPr>
+              <a:spcBef>
+                <a:spcPts val="1200"/>
+              </a:spcBef>
+            </a:pPr>
+            <a:r>
+              <a:rPr sz="1200" b="0">
+                <a:solidFill>
+                  <a:srgbClr val="181510"/>
+                </a:solidFill>
+                <a:latin typeface="Calibri"/>
+              </a:rPr>
+              <a:t>•  Cart persistence</a:t>
+            </a:r>
+          </a:p>
+          <a:p>
+            <a:pPr>
+              <a:spcBef>
+                <a:spcPts val="1200"/>
+              </a:spcBef>
+            </a:pPr>
+            <a:r>
+              <a:rPr sz="1200" b="0">
+                <a:solidFill>
+                  <a:srgbClr val="181510"/>
+                </a:solidFill>
+                <a:latin typeface="Calibri"/>
+              </a:rPr>
+              <a:t>•  Checkout → confirmation</a:t>
+            </a:r>
+          </a:p>
+        </p:txBody>
+      </p:sp>
     </p:spTree>
   </p:cSld>
   <p:clrMapOvr>
@@ -8393,7 +8303,7 @@
                 </a:solidFill>
                 <a:latin typeface="Calibri"/>
               </a:rPr>
-              <a:t>Repository &amp; run</a:t>
+              <a:t>Live demo script (~2 min)</a:t>
             </a:r>
           </a:p>
         </p:txBody>
@@ -8471,7 +8381,7 @@
                 </a:solidFill>
                 <a:latin typeface="Calibri"/>
               </a:rPr>
-              <a:t>github.com/tanmays0/ARCHIVE-APP</a:t>
+              <a:t>Suggested viva walkthrough on Pixel_9</a:t>
             </a:r>
           </a:p>
         </p:txBody>
@@ -8485,7 +8395,7 @@
         <p:spPr>
           <a:xfrm>
             <a:off x="548640" y="1554480"/>
-            <a:ext cx="10972800" cy="4572000"/>
+            <a:ext cx="6400800" cy="4572000"/>
           </a:xfrm>
           <a:prstGeom prst="rect">
             <a:avLst/>
@@ -8500,13 +8410,13 @@
           <a:p>
             <a:pPr algn="l"/>
             <a:r>
-              <a:rPr sz="1800" b="0">
-                <a:solidFill>
-                  <a:srgbClr val="181510"/>
-                </a:solidFill>
-                <a:latin typeface="Calibri"/>
-              </a:rPr>
-              <a:t>•  npm install</a:t>
+              <a:rPr sz="1700" b="0">
+                <a:solidFill>
+                  <a:srgbClr val="181510"/>
+                </a:solidFill>
+                <a:latin typeface="Calibri"/>
+              </a:rPr>
+              <a:t>•  Boot Hello ARCHIVE → Enter</a:t>
             </a:r>
           </a:p>
           <a:p>
@@ -8516,13 +8426,13 @@
               </a:spcBef>
             </a:pPr>
             <a:r>
-              <a:rPr sz="1800" b="0">
-                <a:solidFill>
-                  <a:srgbClr val="181510"/>
-                </a:solidFill>
-                <a:latin typeface="Calibri"/>
-              </a:rPr>
-              <a:t>•  Start Pixel_9 AVD</a:t>
+              <a:rPr sz="1700" b="0">
+                <a:solidFill>
+                  <a:srgbClr val="181510"/>
+                </a:solidFill>
+                <a:latin typeface="Calibri"/>
+              </a:rPr>
+              <a:t>•  Home hero scroll → Shop the Archive</a:t>
             </a:r>
           </a:p>
           <a:p>
@@ -8532,13 +8442,13 @@
               </a:spcBef>
             </a:pPr>
             <a:r>
-              <a:rPr sz="1800" b="0">
-                <a:solidFill>
-                  <a:srgbClr val="181510"/>
-                </a:solidFill>
-                <a:latin typeface="Calibri"/>
-              </a:rPr>
-              <a:t>•  npx expo run:android   (first build is slow)</a:t>
+              <a:rPr sz="1700" b="0">
+                <a:solidFill>
+                  <a:srgbClr val="181510"/>
+                </a:solidFill>
+                <a:latin typeface="Calibri"/>
+              </a:rPr>
+              <a:t>•  Filter catalogue → open a piece → wishlist → add to cart</a:t>
             </a:r>
           </a:p>
           <a:p>
@@ -8548,13 +8458,13 @@
               </a:spcBef>
             </a:pPr>
             <a:r>
-              <a:rPr sz="1800" b="0">
-                <a:solidFill>
-                  <a:srgbClr val="181510"/>
-                </a:solidFill>
-                <a:latin typeface="Calibri"/>
-              </a:rPr>
-              <a:t>•  Day-to-day: adb reverse tcp:8081 + npx expo start</a:t>
+              <a:rPr sz="1700" b="0">
+                <a:solidFill>
+                  <a:srgbClr val="181510"/>
+                </a:solidFill>
+                <a:latin typeface="Calibri"/>
+              </a:rPr>
+              <a:t>•  Cart qty → Checkout → place order → confirmation</a:t>
             </a:r>
           </a:p>
           <a:p>
@@ -8564,13 +8474,13 @@
               </a:spcBef>
             </a:pPr>
             <a:r>
-              <a:rPr sz="1800" b="0">
-                <a:solidFill>
-                  <a:srgbClr val="181510"/>
-                </a:solidFill>
-                <a:latin typeface="Calibri"/>
-              </a:rPr>
-              <a:t>•  npm run typecheck · npm run lint</a:t>
+              <a:rPr sz="1700" b="0">
+                <a:solidFill>
+                  <a:srgbClr val="181510"/>
+                </a:solidFill>
+                <a:latin typeface="Calibri"/>
+              </a:rPr>
+              <a:t>•  Profile → Orders / How we build / Discover more</a:t>
             </a:r>
           </a:p>
           <a:p>
@@ -8580,17 +8490,41 @@
               </a:spcBef>
             </a:pPr>
             <a:r>
-              <a:rPr sz="1800" b="0">
-                <a:solidFill>
-                  <a:srgbClr val="181510"/>
-                </a:solidFill>
-                <a:latin typeface="Calibri"/>
-              </a:rPr>
-              <a:t>•  Report + screenshots also in docs/submission/</a:t>
-            </a:r>
-          </a:p>
-        </p:txBody>
-      </p:sp>
+              <a:rPr sz="1700" b="0">
+                <a:solidFill>
+                  <a:srgbClr val="181510"/>
+                </a:solidFill>
+                <a:latin typeface="Calibri"/>
+              </a:rPr>
+              <a:t>•  Mention INR catalogue + AsyncStorage persistence</a:t>
+            </a:r>
+          </a:p>
+        </p:txBody>
+      </p:sp>
+      <p:pic>
+        <p:nvPicPr>
+          <p:cNvPr id="6" name="Picture 5" descr="01_hello.png"/>
+          <p:cNvPicPr>
+            <a:picLocks noChangeAspect="1"/>
+          </p:cNvPicPr>
+          <p:nvPr/>
+        </p:nvPicPr>
+        <p:blipFill>
+          <a:blip r:embed="rId2"/>
+          <a:stretch>
+            <a:fillRect/>
+          </a:stretch>
+        </p:blipFill>
+        <p:spPr>
+          <a:xfrm>
+            <a:off x="7498079" y="1280160"/>
+            <a:ext cx="2323919" cy="5029200"/>
+          </a:xfrm>
+          <a:prstGeom prst="rect">
+            <a:avLst/>
+          </a:prstGeom>
+        </p:spPr>
+      </p:pic>
     </p:spTree>
   </p:cSld>
   <p:clrMapOvr>
@@ -8600,6 +8534,260 @@
 </file>
 
 <file path=ppt/slides/slide24.xml><?xml version="1.0" encoding="utf-8"?>
+<p:sld xmlns:a="http://schemas.openxmlformats.org/drawingml/2006/main" xmlns:p="http://schemas.openxmlformats.org/presentationml/2006/main" xmlns:r="http://schemas.openxmlformats.org/officeDocument/2006/relationships">
+  <p:cSld>
+    <p:bg>
+      <p:bgPr>
+        <a:solidFill>
+          <a:srgbClr val="F2EEE6"/>
+        </a:solidFill>
+        <a:effectLst/>
+      </p:bgPr>
+    </p:bg>
+    <p:spTree>
+      <p:nvGrpSpPr>
+        <p:cNvPr id="1" name=""/>
+        <p:cNvGrpSpPr/>
+        <p:nvPr/>
+      </p:nvGrpSpPr>
+      <p:grpSpPr/>
+      <p:sp>
+        <p:nvSpPr>
+          <p:cNvPr id="2" name="TextBox 1"/>
+          <p:cNvSpPr txBox="1"/>
+          <p:nvPr/>
+        </p:nvSpPr>
+        <p:spPr>
+          <a:xfrm>
+            <a:off x="548640" y="292608"/>
+            <a:ext cx="10972800" cy="502920"/>
+          </a:xfrm>
+          <a:prstGeom prst="rect">
+            <a:avLst/>
+          </a:prstGeom>
+          <a:noFill/>
+        </p:spPr>
+        <p:txBody>
+          <a:bodyPr wrap="none">
+            <a:spAutoFit/>
+          </a:bodyPr>
+          <a:lstStyle/>
+          <a:p>
+            <a:pPr algn="l"/>
+            <a:r>
+              <a:rPr sz="2600" b="1">
+                <a:solidFill>
+                  <a:srgbClr val="181510"/>
+                </a:solidFill>
+                <a:latin typeface="Calibri"/>
+              </a:rPr>
+              <a:t>Repository &amp; run</a:t>
+            </a:r>
+          </a:p>
+        </p:txBody>
+      </p:sp>
+      <p:sp>
+        <p:nvSpPr>
+          <p:cNvPr id="3" name="Rectangle 2"/>
+          <p:cNvSpPr/>
+          <p:nvPr/>
+        </p:nvSpPr>
+        <p:spPr>
+          <a:xfrm>
+            <a:off x="548640" y="914400"/>
+            <a:ext cx="1097280" cy="54864"/>
+          </a:xfrm>
+          <a:prstGeom prst="rect">
+            <a:avLst/>
+          </a:prstGeom>
+          <a:solidFill>
+            <a:srgbClr val="A9522F"/>
+          </a:solidFill>
+          <a:ln>
+            <a:noFill/>
+          </a:ln>
+        </p:spPr>
+        <p:style>
+          <a:lnRef idx="1">
+            <a:schemeClr val="accent1"/>
+          </a:lnRef>
+          <a:fillRef idx="3">
+            <a:schemeClr val="accent1"/>
+          </a:fillRef>
+          <a:effectRef idx="2">
+            <a:schemeClr val="accent1"/>
+          </a:effectRef>
+          <a:fontRef idx="minor">
+            <a:schemeClr val="lt1"/>
+          </a:fontRef>
+        </p:style>
+        <p:txBody>
+          <a:bodyPr rtlCol="0" anchor="ctr"/>
+          <a:lstStyle/>
+          <a:p>
+            <a:pPr algn="ctr"/>
+          </a:p>
+        </p:txBody>
+      </p:sp>
+      <p:sp>
+        <p:nvSpPr>
+          <p:cNvPr id="4" name="TextBox 3"/>
+          <p:cNvSpPr txBox="1"/>
+          <p:nvPr/>
+        </p:nvSpPr>
+        <p:spPr>
+          <a:xfrm>
+            <a:off x="548640" y="1051560"/>
+            <a:ext cx="10972800" cy="365760"/>
+          </a:xfrm>
+          <a:prstGeom prst="rect">
+            <a:avLst/>
+          </a:prstGeom>
+          <a:noFill/>
+        </p:spPr>
+        <p:txBody>
+          <a:bodyPr wrap="none">
+            <a:spAutoFit/>
+          </a:bodyPr>
+          <a:lstStyle/>
+          <a:p>
+            <a:pPr algn="l"/>
+            <a:r>
+              <a:rPr sz="1400" b="0">
+                <a:solidFill>
+                  <a:srgbClr val="5C5648"/>
+                </a:solidFill>
+                <a:latin typeface="Calibri"/>
+              </a:rPr>
+              <a:t>github.com/tanmays0/ARCHIVE-APP</a:t>
+            </a:r>
+          </a:p>
+        </p:txBody>
+      </p:sp>
+      <p:sp>
+        <p:nvSpPr>
+          <p:cNvPr id="5" name="TextBox 4"/>
+          <p:cNvSpPr txBox="1"/>
+          <p:nvPr/>
+        </p:nvSpPr>
+        <p:spPr>
+          <a:xfrm>
+            <a:off x="548640" y="1554480"/>
+            <a:ext cx="10972800" cy="4572000"/>
+          </a:xfrm>
+          <a:prstGeom prst="rect">
+            <a:avLst/>
+          </a:prstGeom>
+          <a:noFill/>
+        </p:spPr>
+        <p:txBody>
+          <a:bodyPr wrap="none">
+            <a:spAutoFit/>
+          </a:bodyPr>
+          <a:lstStyle/>
+          <a:p>
+            <a:pPr algn="l"/>
+            <a:r>
+              <a:rPr sz="1800" b="0">
+                <a:solidFill>
+                  <a:srgbClr val="181510"/>
+                </a:solidFill>
+                <a:latin typeface="Calibri"/>
+              </a:rPr>
+              <a:t>•  npm install</a:t>
+            </a:r>
+          </a:p>
+          <a:p>
+            <a:pPr>
+              <a:spcBef>
+                <a:spcPts val="1200"/>
+              </a:spcBef>
+            </a:pPr>
+            <a:r>
+              <a:rPr sz="1800" b="0">
+                <a:solidFill>
+                  <a:srgbClr val="181510"/>
+                </a:solidFill>
+                <a:latin typeface="Calibri"/>
+              </a:rPr>
+              <a:t>•  Start Pixel_9 AVD</a:t>
+            </a:r>
+          </a:p>
+          <a:p>
+            <a:pPr>
+              <a:spcBef>
+                <a:spcPts val="1200"/>
+              </a:spcBef>
+            </a:pPr>
+            <a:r>
+              <a:rPr sz="1800" b="0">
+                <a:solidFill>
+                  <a:srgbClr val="181510"/>
+                </a:solidFill>
+                <a:latin typeface="Calibri"/>
+              </a:rPr>
+              <a:t>•  npx expo run:android   (first build is slow)</a:t>
+            </a:r>
+          </a:p>
+          <a:p>
+            <a:pPr>
+              <a:spcBef>
+                <a:spcPts val="1200"/>
+              </a:spcBef>
+            </a:pPr>
+            <a:r>
+              <a:rPr sz="1800" b="0">
+                <a:solidFill>
+                  <a:srgbClr val="181510"/>
+                </a:solidFill>
+                <a:latin typeface="Calibri"/>
+              </a:rPr>
+              <a:t>•  Day-to-day: adb reverse tcp:8081 + npx expo start</a:t>
+            </a:r>
+          </a:p>
+          <a:p>
+            <a:pPr>
+              <a:spcBef>
+                <a:spcPts val="1200"/>
+              </a:spcBef>
+            </a:pPr>
+            <a:r>
+              <a:rPr sz="1800" b="0">
+                <a:solidFill>
+                  <a:srgbClr val="181510"/>
+                </a:solidFill>
+                <a:latin typeface="Calibri"/>
+              </a:rPr>
+              <a:t>•  npm run typecheck · npm run lint</a:t>
+            </a:r>
+          </a:p>
+          <a:p>
+            <a:pPr>
+              <a:spcBef>
+                <a:spcPts val="1200"/>
+              </a:spcBef>
+            </a:pPr>
+            <a:r>
+              <a:rPr sz="1800" b="0">
+                <a:solidFill>
+                  <a:srgbClr val="181510"/>
+                </a:solidFill>
+                <a:latin typeface="Calibri"/>
+              </a:rPr>
+              <a:t>•  Report + screenshots also in docs/submission/</a:t>
+            </a:r>
+          </a:p>
+        </p:txBody>
+      </p:sp>
+    </p:spTree>
+  </p:cSld>
+  <p:clrMapOvr>
+    <a:masterClrMapping/>
+  </p:clrMapOvr>
+</p:sld>
+</file>
+
+<file path=ppt/slides/slide25.xml><?xml version="1.0" encoding="utf-8"?>
 <p:sld xmlns:a="http://schemas.openxmlformats.org/drawingml/2006/main" xmlns:p="http://schemas.openxmlformats.org/presentationml/2006/main" xmlns:r="http://schemas.openxmlformats.org/officeDocument/2006/relationships">
   <p:cSld>
     <p:bg>

</xml_diff>